<commit_message>
updated linked list quiz
</commit_message>
<xml_diff>
--- a/notes/week13/OnotationGuide.pptx
+++ b/notes/week13/OnotationGuide.pptx
@@ -157,7 +157,7 @@
 <file path=ppt/revisionInfo.xml><?xml version="1.0" encoding="utf-8"?>
 <p1510:revInfo xmlns:a="http://schemas.openxmlformats.org/drawingml/2006/main" xmlns:r="http://schemas.openxmlformats.org/officeDocument/2006/relationships" xmlns:p1510="http://schemas.microsoft.com/office/powerpoint/2015/10/main">
   <p1510:revLst>
-    <p1510:client id="{D65443A7-DBC8-AB4A-80BB-F40C3BD45101}" v="107" dt="2026-03-25T19:11:42.594"/>
+    <p1510:client id="{D65443A7-DBC8-AB4A-80BB-F40C3BD45101}" v="108" dt="2026-03-30T20:55:55.082"/>
   </p1510:revLst>
 </p1510:revInfo>
 </file>
@@ -167,7 +167,7 @@
   <pc:docChgLst>
     <pc:chgData name="Toby Donaldson" userId="2e6e5431-bb17-4c41-9985-d39c50d83c73" providerId="ADAL" clId="{F31BC264-820E-54C4-A6D1-F92AF9CC222E}"/>
     <pc:docChg chg="custSel addSld modSld">
-      <pc:chgData name="Toby Donaldson" userId="2e6e5431-bb17-4c41-9985-d39c50d83c73" providerId="ADAL" clId="{F31BC264-820E-54C4-A6D1-F92AF9CC222E}" dt="2026-03-25T19:12:58.391" v="174" actId="21"/>
+      <pc:chgData name="Toby Donaldson" userId="2e6e5431-bb17-4c41-9985-d39c50d83c73" providerId="ADAL" clId="{F31BC264-820E-54C4-A6D1-F92AF9CC222E}" dt="2026-03-30T20:55:55.077" v="175"/>
       <pc:docMkLst>
         <pc:docMk/>
       </pc:docMkLst>
@@ -216,8 +216,8 @@
           </ac:spMkLst>
         </pc:spChg>
       </pc:sldChg>
-      <pc:sldChg chg="modSp">
-        <pc:chgData name="Toby Donaldson" userId="2e6e5431-bb17-4c41-9985-d39c50d83c73" providerId="ADAL" clId="{F31BC264-820E-54C4-A6D1-F92AF9CC222E}" dt="2026-03-25T17:35:54.864" v="64" actId="207"/>
+      <pc:sldChg chg="addSp modSp">
+        <pc:chgData name="Toby Donaldson" userId="2e6e5431-bb17-4c41-9985-d39c50d83c73" providerId="ADAL" clId="{F31BC264-820E-54C4-A6D1-F92AF9CC222E}" dt="2026-03-30T20:55:55.077" v="175"/>
         <pc:sldMkLst>
           <pc:docMk/>
           <pc:sldMk cId="801713502" sldId="266"/>
@@ -230,9 +230,17 @@
             <ac:spMk id="3" creationId="{7A1CFFD1-E717-CB67-CF25-1F36DDB7864D}"/>
           </ac:spMkLst>
         </pc:spChg>
+        <pc:inkChg chg="add">
+          <ac:chgData name="Toby Donaldson" userId="2e6e5431-bb17-4c41-9985-d39c50d83c73" providerId="ADAL" clId="{F31BC264-820E-54C4-A6D1-F92AF9CC222E}" dt="2026-03-30T20:55:55.077" v="175"/>
+          <ac:inkMkLst>
+            <pc:docMk/>
+            <pc:sldMk cId="801713502" sldId="266"/>
+            <ac:inkMk id="4" creationId="{8F393F8E-8C9E-1F10-D285-9D8B977FB176}"/>
+          </ac:inkMkLst>
+        </pc:inkChg>
       </pc:sldChg>
-      <pc:sldChg chg="modSp mod">
-        <pc:chgData name="Toby Donaldson" userId="2e6e5431-bb17-4c41-9985-d39c50d83c73" providerId="ADAL" clId="{F31BC264-820E-54C4-A6D1-F92AF9CC222E}" dt="2026-03-25T18:20:58.256" v="99" actId="207"/>
+      <pc:sldChg chg="addSp modSp mod">
+        <pc:chgData name="Toby Donaldson" userId="2e6e5431-bb17-4c41-9985-d39c50d83c73" providerId="ADAL" clId="{F31BC264-820E-54C4-A6D1-F92AF9CC222E}" dt="2026-03-30T20:55:55.077" v="175"/>
         <pc:sldMkLst>
           <pc:docMk/>
           <pc:sldMk cId="2107447322" sldId="267"/>
@@ -245,9 +253,17 @@
             <ac:spMk id="3" creationId="{65FC068E-CA85-45E2-BCC2-76EEC453895D}"/>
           </ac:spMkLst>
         </pc:spChg>
+        <pc:inkChg chg="add">
+          <ac:chgData name="Toby Donaldson" userId="2e6e5431-bb17-4c41-9985-d39c50d83c73" providerId="ADAL" clId="{F31BC264-820E-54C4-A6D1-F92AF9CC222E}" dt="2026-03-30T20:55:55.077" v="175"/>
+          <ac:inkMkLst>
+            <pc:docMk/>
+            <pc:sldMk cId="2107447322" sldId="267"/>
+            <ac:inkMk id="4" creationId="{73B5DED4-5C3A-2560-09BD-2F9CD09382BD}"/>
+          </ac:inkMkLst>
+        </pc:inkChg>
       </pc:sldChg>
-      <pc:sldChg chg="modSp mod">
-        <pc:chgData name="Toby Donaldson" userId="2e6e5431-bb17-4c41-9985-d39c50d83c73" providerId="ADAL" clId="{F31BC264-820E-54C4-A6D1-F92AF9CC222E}" dt="2026-03-25T19:07:46.504" v="110" actId="20577"/>
+      <pc:sldChg chg="addSp modSp mod">
+        <pc:chgData name="Toby Donaldson" userId="2e6e5431-bb17-4c41-9985-d39c50d83c73" providerId="ADAL" clId="{F31BC264-820E-54C4-A6D1-F92AF9CC222E}" dt="2026-03-30T20:55:55.077" v="175"/>
         <pc:sldMkLst>
           <pc:docMk/>
           <pc:sldMk cId="1736438042" sldId="268"/>
@@ -260,9 +276,17 @@
             <ac:spMk id="3" creationId="{C1E82CD1-110D-0451-8FAB-63E0E625C881}"/>
           </ac:spMkLst>
         </pc:spChg>
+        <pc:inkChg chg="add">
+          <ac:chgData name="Toby Donaldson" userId="2e6e5431-bb17-4c41-9985-d39c50d83c73" providerId="ADAL" clId="{F31BC264-820E-54C4-A6D1-F92AF9CC222E}" dt="2026-03-30T20:55:55.077" v="175"/>
+          <ac:inkMkLst>
+            <pc:docMk/>
+            <pc:sldMk cId="1736438042" sldId="268"/>
+            <ac:inkMk id="4" creationId="{3792D865-ED40-AEBD-29B9-CF77BADBFF2C}"/>
+          </ac:inkMkLst>
+        </pc:inkChg>
       </pc:sldChg>
-      <pc:sldChg chg="modSp">
-        <pc:chgData name="Toby Donaldson" userId="2e6e5431-bb17-4c41-9985-d39c50d83c73" providerId="ADAL" clId="{F31BC264-820E-54C4-A6D1-F92AF9CC222E}" dt="2026-03-25T19:08:06.447" v="121" actId="20577"/>
+      <pc:sldChg chg="addSp modSp">
+        <pc:chgData name="Toby Donaldson" userId="2e6e5431-bb17-4c41-9985-d39c50d83c73" providerId="ADAL" clId="{F31BC264-820E-54C4-A6D1-F92AF9CC222E}" dt="2026-03-30T20:55:55.077" v="175"/>
         <pc:sldMkLst>
           <pc:docMk/>
           <pc:sldMk cId="2205308434" sldId="270"/>
@@ -275,6 +299,29 @@
             <ac:spMk id="3" creationId="{F1E8AF7C-1C55-4E0B-971D-1F2FD5805501}"/>
           </ac:spMkLst>
         </pc:spChg>
+        <pc:inkChg chg="add">
+          <ac:chgData name="Toby Donaldson" userId="2e6e5431-bb17-4c41-9985-d39c50d83c73" providerId="ADAL" clId="{F31BC264-820E-54C4-A6D1-F92AF9CC222E}" dt="2026-03-30T20:55:55.077" v="175"/>
+          <ac:inkMkLst>
+            <pc:docMk/>
+            <pc:sldMk cId="2205308434" sldId="270"/>
+            <ac:inkMk id="4" creationId="{E7DD8CD8-0E6D-AD9E-716A-25B0296D84D2}"/>
+          </ac:inkMkLst>
+        </pc:inkChg>
+      </pc:sldChg>
+      <pc:sldChg chg="addSp">
+        <pc:chgData name="Toby Donaldson" userId="2e6e5431-bb17-4c41-9985-d39c50d83c73" providerId="ADAL" clId="{F31BC264-820E-54C4-A6D1-F92AF9CC222E}" dt="2026-03-30T20:55:55.077" v="175"/>
+        <pc:sldMkLst>
+          <pc:docMk/>
+          <pc:sldMk cId="642371157" sldId="271"/>
+        </pc:sldMkLst>
+        <pc:inkChg chg="add">
+          <ac:chgData name="Toby Donaldson" userId="2e6e5431-bb17-4c41-9985-d39c50d83c73" providerId="ADAL" clId="{F31BC264-820E-54C4-A6D1-F92AF9CC222E}" dt="2026-03-30T20:55:55.077" v="175"/>
+          <ac:inkMkLst>
+            <pc:docMk/>
+            <pc:sldMk cId="642371157" sldId="271"/>
+            <ac:inkMk id="4" creationId="{CFFB0C25-5C16-16AA-E3F3-33E87CB767F8}"/>
+          </ac:inkMkLst>
+        </pc:inkChg>
       </pc:sldChg>
       <pc:sldChg chg="modSp mod">
         <pc:chgData name="Toby Donaldson" userId="2e6e5431-bb17-4c41-9985-d39c50d83c73" providerId="ADAL" clId="{F31BC264-820E-54C4-A6D1-F92AF9CC222E}" dt="2026-03-25T19:08:32.619" v="126" actId="207"/>
@@ -381,8 +428,8 @@
           </ac:spMkLst>
         </pc:spChg>
       </pc:sldChg>
-      <pc:sldChg chg="modSp mod">
-        <pc:chgData name="Toby Donaldson" userId="2e6e5431-bb17-4c41-9985-d39c50d83c73" providerId="ADAL" clId="{F31BC264-820E-54C4-A6D1-F92AF9CC222E}" dt="2026-03-25T19:10:39.241" v="153" actId="12385"/>
+      <pc:sldChg chg="addSp modSp mod">
+        <pc:chgData name="Toby Donaldson" userId="2e6e5431-bb17-4c41-9985-d39c50d83c73" providerId="ADAL" clId="{F31BC264-820E-54C4-A6D1-F92AF9CC222E}" dt="2026-03-30T20:55:55.077" v="175"/>
         <pc:sldMkLst>
           <pc:docMk/>
           <pc:sldMk cId="1760266680" sldId="289"/>
@@ -395,9 +442,17 @@
             <ac:graphicFrameMk id="6" creationId="{1714D35B-00D2-C2F0-D9AA-13B9A53A6A93}"/>
           </ac:graphicFrameMkLst>
         </pc:graphicFrameChg>
+        <pc:inkChg chg="add">
+          <ac:chgData name="Toby Donaldson" userId="2e6e5431-bb17-4c41-9985-d39c50d83c73" providerId="ADAL" clId="{F31BC264-820E-54C4-A6D1-F92AF9CC222E}" dt="2026-03-30T20:55:55.077" v="175"/>
+          <ac:inkMkLst>
+            <pc:docMk/>
+            <pc:sldMk cId="1760266680" sldId="289"/>
+            <ac:inkMk id="3" creationId="{94E6AD5E-B385-E95E-E689-3E9F56B8868E}"/>
+          </ac:inkMkLst>
+        </pc:inkChg>
       </pc:sldChg>
-      <pc:sldChg chg="modSp mod">
-        <pc:chgData name="Toby Donaldson" userId="2e6e5431-bb17-4c41-9985-d39c50d83c73" providerId="ADAL" clId="{F31BC264-820E-54C4-A6D1-F92AF9CC222E}" dt="2026-03-25T19:10:49.477" v="154" actId="20577"/>
+      <pc:sldChg chg="addSp modSp mod">
+        <pc:chgData name="Toby Donaldson" userId="2e6e5431-bb17-4c41-9985-d39c50d83c73" providerId="ADAL" clId="{F31BC264-820E-54C4-A6D1-F92AF9CC222E}" dt="2026-03-30T20:55:55.077" v="175"/>
         <pc:sldMkLst>
           <pc:docMk/>
           <pc:sldMk cId="3346474797" sldId="290"/>
@@ -410,9 +465,17 @@
             <ac:spMk id="2" creationId="{CA88D2E0-9EA6-6C47-9664-766C978E8464}"/>
           </ac:spMkLst>
         </pc:spChg>
+        <pc:inkChg chg="add">
+          <ac:chgData name="Toby Donaldson" userId="2e6e5431-bb17-4c41-9985-d39c50d83c73" providerId="ADAL" clId="{F31BC264-820E-54C4-A6D1-F92AF9CC222E}" dt="2026-03-30T20:55:55.077" v="175"/>
+          <ac:inkMkLst>
+            <pc:docMk/>
+            <pc:sldMk cId="3346474797" sldId="290"/>
+            <ac:inkMk id="4" creationId="{CC49B7AE-68BF-276D-43BB-7DA43AD7AEA9}"/>
+          </ac:inkMkLst>
+        </pc:inkChg>
       </pc:sldChg>
-      <pc:sldChg chg="modSp mod">
-        <pc:chgData name="Toby Donaldson" userId="2e6e5431-bb17-4c41-9985-d39c50d83c73" providerId="ADAL" clId="{F31BC264-820E-54C4-A6D1-F92AF9CC222E}" dt="2026-03-25T19:11:12.907" v="158" actId="20577"/>
+      <pc:sldChg chg="addSp modSp mod">
+        <pc:chgData name="Toby Donaldson" userId="2e6e5431-bb17-4c41-9985-d39c50d83c73" providerId="ADAL" clId="{F31BC264-820E-54C4-A6D1-F92AF9CC222E}" dt="2026-03-30T20:55:55.077" v="175"/>
         <pc:sldMkLst>
           <pc:docMk/>
           <pc:sldMk cId="2228665987" sldId="291"/>
@@ -425,6 +488,14 @@
             <ac:spMk id="2" creationId="{594E3DE2-30C5-6DEC-F9AE-58E0726B513F}"/>
           </ac:spMkLst>
         </pc:spChg>
+        <pc:inkChg chg="add">
+          <ac:chgData name="Toby Donaldson" userId="2e6e5431-bb17-4c41-9985-d39c50d83c73" providerId="ADAL" clId="{F31BC264-820E-54C4-A6D1-F92AF9CC222E}" dt="2026-03-30T20:55:55.077" v="175"/>
+          <ac:inkMkLst>
+            <pc:docMk/>
+            <pc:sldMk cId="2228665987" sldId="291"/>
+            <ac:inkMk id="4" creationId="{E44B9B83-D443-72E0-6C8A-427AF5677ECA}"/>
+          </ac:inkMkLst>
+        </pc:inkChg>
       </pc:sldChg>
       <pc:sldChg chg="modSp mod">
         <pc:chgData name="Toby Donaldson" userId="2e6e5431-bb17-4c41-9985-d39c50d83c73" providerId="ADAL" clId="{F31BC264-820E-54C4-A6D1-F92AF9CC222E}" dt="2026-03-25T19:10:57.292" v="155" actId="20577"/>
@@ -456,8 +527,8 @@
           </ac:spMkLst>
         </pc:spChg>
       </pc:sldChg>
-      <pc:sldChg chg="modSp mod">
-        <pc:chgData name="Toby Donaldson" userId="2e6e5431-bb17-4c41-9985-d39c50d83c73" providerId="ADAL" clId="{F31BC264-820E-54C4-A6D1-F92AF9CC222E}" dt="2026-03-25T19:11:08.027" v="157" actId="20577"/>
+      <pc:sldChg chg="addSp modSp mod">
+        <pc:chgData name="Toby Donaldson" userId="2e6e5431-bb17-4c41-9985-d39c50d83c73" providerId="ADAL" clId="{F31BC264-820E-54C4-A6D1-F92AF9CC222E}" dt="2026-03-30T20:55:55.077" v="175"/>
         <pc:sldMkLst>
           <pc:docMk/>
           <pc:sldMk cId="3935162255" sldId="294"/>
@@ -470,6 +541,14 @@
             <ac:spMk id="2" creationId="{ED08B9EB-1874-B924-F6F2-8ED41FC1075E}"/>
           </ac:spMkLst>
         </pc:spChg>
+        <pc:inkChg chg="add">
+          <ac:chgData name="Toby Donaldson" userId="2e6e5431-bb17-4c41-9985-d39c50d83c73" providerId="ADAL" clId="{F31BC264-820E-54C4-A6D1-F92AF9CC222E}" dt="2026-03-30T20:55:55.077" v="175"/>
+          <ac:inkMkLst>
+            <pc:docMk/>
+            <pc:sldMk cId="3935162255" sldId="294"/>
+            <ac:inkMk id="4" creationId="{3BF4E456-0989-9D62-AAAB-F0351919CDA5}"/>
+          </ac:inkMkLst>
+        </pc:inkChg>
       </pc:sldChg>
       <pc:sldChg chg="modSp mod">
         <pc:chgData name="Toby Donaldson" userId="2e6e5431-bb17-4c41-9985-d39c50d83c73" providerId="ADAL" clId="{F31BC264-820E-54C4-A6D1-F92AF9CC222E}" dt="2026-03-25T19:11:17.104" v="159" actId="20577"/>
@@ -487,19 +566,19 @@
         </pc:spChg>
       </pc:sldChg>
       <pc:sldChg chg="addSp delSp modSp mod">
-        <pc:chgData name="Toby Donaldson" userId="2e6e5431-bb17-4c41-9985-d39c50d83c73" providerId="ADAL" clId="{F31BC264-820E-54C4-A6D1-F92AF9CC222E}" dt="2026-03-25T19:12:58.391" v="174" actId="21"/>
+        <pc:chgData name="Toby Donaldson" userId="2e6e5431-bb17-4c41-9985-d39c50d83c73" providerId="ADAL" clId="{F31BC264-820E-54C4-A6D1-F92AF9CC222E}" dt="2026-03-30T20:55:55.077" v="175"/>
         <pc:sldMkLst>
           <pc:docMk/>
           <pc:sldMk cId="1501517616" sldId="296"/>
         </pc:sldMkLst>
-        <pc:spChg chg="add del mod">
-          <ac:chgData name="Toby Donaldson" userId="2e6e5431-bb17-4c41-9985-d39c50d83c73" providerId="ADAL" clId="{F31BC264-820E-54C4-A6D1-F92AF9CC222E}" dt="2026-03-25T19:12:58.391" v="174" actId="21"/>
-          <ac:spMkLst>
+        <pc:inkChg chg="add">
+          <ac:chgData name="Toby Donaldson" userId="2e6e5431-bb17-4c41-9985-d39c50d83c73" providerId="ADAL" clId="{F31BC264-820E-54C4-A6D1-F92AF9CC222E}" dt="2026-03-30T20:55:55.077" v="175"/>
+          <ac:inkMkLst>
             <pc:docMk/>
             <pc:sldMk cId="1501517616" sldId="296"/>
-            <ac:spMk id="4" creationId="{10F7C199-2304-3591-D56D-D8203C00B23E}"/>
-          </ac:spMkLst>
-        </pc:spChg>
+            <ac:inkMk id="4" creationId="{576F59BB-4F0B-C277-980F-51CD69BDA6D2}"/>
+          </ac:inkMkLst>
+        </pc:inkChg>
       </pc:sldChg>
       <pc:sldChg chg="add">
         <pc:chgData name="Toby Donaldson" userId="2e6e5431-bb17-4c41-9985-d39c50d83c73" providerId="ADAL" clId="{F31BC264-820E-54C4-A6D1-F92AF9CC222E}" dt="2026-03-25T19:08:25.122" v="122" actId="2890"/>
@@ -525,6 +604,294 @@
     </pc:docChg>
   </pc:docChgLst>
 </pc:chgInfo>
+</file>
+
+<file path=ppt/ink/ink1.xml><?xml version="1.0" encoding="utf-8"?>
+<inkml:ink xmlns:inkml="http://www.w3.org/2003/InkML">
+  <inkml:definitions>
+    <inkml:context xml:id="ctx0">
+      <inkml:inkSource xml:id="inkSrc0">
+        <inkml:traceFormat>
+          <inkml:channel name="X" type="integer" min="-2.14748E9" max="2.14748E9" units="cm"/>
+          <inkml:channel name="Y" type="integer" min="-2.14748E9" max="2.14748E9" units="cm"/>
+          <inkml:channel name="F" type="integer" max="32767" units="dev"/>
+        </inkml:traceFormat>
+        <inkml:channelProperties>
+          <inkml:channelProperty channel="X" name="resolution" value="1000" units="1/cm"/>
+          <inkml:channelProperty channel="Y" name="resolution" value="1000" units="1/cm"/>
+          <inkml:channelProperty channel="F" name="resolution" value="0" units="1/dev"/>
+        </inkml:channelProperties>
+      </inkml:inkSource>
+      <inkml:timestamp xml:id="ts0" timeString="2026-03-30T20:38:53.500"/>
+    </inkml:context>
+    <inkml:brush xml:id="br0">
+      <inkml:brushProperty name="width" value="0.05292" units="cm"/>
+      <inkml:brushProperty name="height" value="0.05292" units="cm"/>
+      <inkml:brushProperty name="color" value="#FF0000"/>
+    </inkml:brush>
+  </inkml:definitions>
+  <inkml:trace contextRef="#ctx0" brushRef="#br0">3069 12171 24575,'20'0'0,"-5"0"0,-15 0 0,16 0 0,12 0 0,9 0 0,-12 0 0,1 0 0,11 0 0,6 0 0,0 0 0,-6 0 0,3 0 0,4 0 0,4 0-412,-2 0 0,5 0 0,-1 0 412,-2 1 0,0-1 0,1-1 0,-6-4 0,1-2 0,0 1 0,-1 0 0,7 4 0,-3 2 0,1-4 0,-10-4 0,0-3 0,-1-1 0,-3 4 0,10 6 0,-3 0 0,3-6 0,-6 1 0,-17 7 0,3 0 0,-24 0 0,0 0 0,0 0 0</inkml:trace>
+</inkml:ink>
+</file>
+
+<file path=ppt/ink/ink10.xml><?xml version="1.0" encoding="utf-8"?>
+<inkml:ink xmlns:inkml="http://www.w3.org/2003/InkML">
+  <inkml:definitions>
+    <inkml:context xml:id="ctx0">
+      <inkml:inkSource xml:id="inkSrc0">
+        <inkml:traceFormat>
+          <inkml:channel name="X" type="integer" min="-2.14748E9" max="2.14748E9" units="cm"/>
+          <inkml:channel name="Y" type="integer" min="-2.14748E9" max="2.14748E9" units="cm"/>
+          <inkml:channel name="F" type="integer" max="32767" units="dev"/>
+        </inkml:traceFormat>
+        <inkml:channelProperties>
+          <inkml:channelProperty channel="X" name="resolution" value="1000" units="1/cm"/>
+          <inkml:channelProperty channel="Y" name="resolution" value="1000" units="1/cm"/>
+          <inkml:channelProperty channel="F" name="resolution" value="0" units="1/dev"/>
+        </inkml:channelProperties>
+      </inkml:inkSource>
+      <inkml:timestamp xml:id="ts0" timeString="2026-03-30T20:55:22.395"/>
+    </inkml:context>
+    <inkml:brush xml:id="br0">
+      <inkml:brushProperty name="width" value="0.05292" units="cm"/>
+      <inkml:brushProperty name="height" value="0.05292" units="cm"/>
+      <inkml:brushProperty name="color" value="#FF0000"/>
+    </inkml:brush>
+  </inkml:definitions>
+  <inkml:trace contextRef="#ctx0" brushRef="#br0">1393 7214 24575,'0'30'0,"0"-4"0,0 3 0,0 18 0,0-9 0,0 4 0,0 1 0,0 2-527,0-7 1,0 3 0,0 0 526,0 3 0,0 1 0,0 1 0,0-7 0,0 2 0,0 0 0,0-1 0,0-2 0,0 0 0,0-1 0,0 1 0,0 9 0,0-1 0,0 0 0,0-2 0,0 0 0,0-1 0,0-1 0,-1 1 0,2-3-44,4-3 1,1-1 0,-1-1 43,-3 0 0,-2 0 0,2-3 0,6 1 0,0-1 0,-8 6 0,0 0 0,7-10 0,1-1 0,-6 0 0,0-1 1165,14 17-1165,-16 0 544,0-5-544,0-13 0,0 1 0,0 11 0,0 6 0,0-24 0,0 21 0,0-19 0,0 22 0,24-23 0,-19 19 0,19-33 0,-24 18 0,16-24 0,3 0 0,1 0 0,6 0 0,3 0 0,20 0 0,-7 0 0,4 0 0,-12 0 0,1 0 0,0 0-349,0 0 1,1 0 0,1 0 348,7 0 0,3 0 0,1 0 0,-11 0 0,0 0 0,1 0 0,1 0-513,2 0 0,1 0 0,0 0 0,1 0 513,3 0 0,0 0 0,0 0 0,0 0 0,-1 0 0,0 0 0,-1 0 0,1 0 0,-1 0 0,0 0 0,0 0 0,0 0 0,0 0 0,0 0 0,-1 0 0,1 0-331,-4 0 1,-1 0 0,1 0-1,1 0 331,6 0 0,0 0 0,2 0 0,-2 0 0,0 0 0,-1 0 0,1 0 0,2 0-431,-10 0 0,3 0 1,0 0-1,1 0 0,0 0 1,-2 0 430,7 0 0,-1 0 0,0 0 0,0 0 0,2 0 0,-5 0 0,0 0 0,2 1 0,-1-1 0,1 0 0,-1-1 0,0-2 0,1-1 0,-1-1 0,0 0 0,0 1 0,-1 1 0,-1 1 0,-1 1 0,-1 1 0,1 0 0,0-1 0,1-1 0,5-1 0,1-1 0,1-1 0,0 0 0,-1 1 0,-1 2 0,-5 0 0,-1 2 0,0 0 0,-1 1 0,1-1 0,1 1 0,5-1 0,1 0 0,1 0 0,0 0 0,-1 0 0,-1 0 0,-5 0 0,-1 0 0,-1 0 0,1 0 0,0 0 0,1 0 0,5 0 0,1 0 0,1 0 0,0 0 0,-1 0 0,-1 0 0,-5 0 0,-1 0 0,-1 0 0,1 1 0,0-2 0,1 1 0,5-2 0,1-1 0,1 0 0,0 0 0,-1 0 0,-1 1 0,-5 1 0,-1 0 0,0 1 0,-1 0 0,1-1 0,1 0 0,1-1 0,1 0 0,1-1 0,-1 0 0,0 0 0,0 0 0,-2 1 0,0-1 0,-1 0 0,0 0 0,1 1 0,-1 0 0,8 1 0,-1 1 0,1 0 0,0 0 0,0-3 0,-8-2 0,1-2 0,-1-1 0,1 0 0,-1 2 0,0 1 0,8 2 0,-1 2 0,0 1 0,1-1 0,-1 0 0,-6-2 0,-1-1 0,1 0 0,0-1 0,-1 1 0,0 0 0,5 0 0,0 1 0,0 0 0,-1 0 0,0 0-215,2 2 1,-1 1-1,1 0 1,-1-1-1,-1 0 215,-5-2 0,0-1 0,-1 1 0,1-1 0,-1 2 0,2 1 0,1 1 0,-1 0 0,0 1 0,-1-1 0,7 0 0,-1 0 0,0 0 0,-1 0 32,1 0 1,-1 0 0,0 0 0,-1 0-33,0 0 0,-2 0 0,1 0 0,-1 0 0,-3 0 0,0 0 0,0 0 0,1 0 0,2 0 0,1 0 0,0 0 0,-1 0 0,-2 0 0,-2 0 0,1 0 0,1 0 3,2 0 0,2 0 0,-1 0 0,-2 0-3,7 0 0,-2 0 0,2 0 0,-3 0 0,1 0 0,0 0 0,-1 0 0,-6 0 0,-2 0 0,1 0 0,1 0 186,9 0 1,1 0 0,1 0 0,-1 0-187,-1 0 0,-1 0 0,0 0 0,1 0 0,-9 0 0,1 0 0,-1 0 0,1 0 0,1 0-41,3 0 0,0 0 0,0 0 0,1 0 0,0 0 41,2 0 0,-1 0 0,1 0 0,0 0 0,0 0 0,2 0 0,-1 0 0,0 0 0,1 0 0,1 0-259,-3 0 1,1 0 0,0 0 0,1 0 0,-1 0 0,0 0 258,-2 0 0,0 0 0,-1 0 0,0 0 0,1 0 0,1 0 0,-5 0 0,1 0 0,0 0 0,0 0 0,0 0 0,0 0 0,0 0 0,6 0 0,0 0 0,-1 0 0,1 0 0,-1 0 0,1 0 0,-6 0 0,0 0 0,-1 0 0,1 0 0,0 0 0,1 0 0,-1 0 0,1 0 0,0 0 0,0 0 0,1 0 0,0 0 0,0 0 0,0 0-263,-2 0 0,1 0 1,0 0-1,0 0 1,0 0-1,0 0 0,0 0 1,0 0 262,4 0 0,-1 0 0,1 0 0,-1 0 0,0 0 0,1 0 0,1 0-200,-2 0 1,0 0-1,1 0 1,0 0 0,0 0-1,0 0 1,0 0-1,0 0 200,-1 0 0,0 0 0,0 0 0,0 0 0,0 0 0,0 0 0,-1 0 0,0 0 0,-1 0 0,-1 0 0,-1 0 0,1 0 0,-1 0 0,1 0 0,1 0 0,0 0 0,-2 0 0,1 0 0,1 0 0,0 0 0,0 0 0,0 0 0,0 0 0,-1 0 0,0 0 0,4 0 0,-1 0 0,0 0 0,0 0 0,-1 0 0,1 0 0,0 0 0,1 0-150,-5 0 0,0 0 0,1 0 0,0 0 0,-1 0 0,1 0 1,0 0-1,1 0 0,-1 0 150,3 0 0,0 0 0,1 0 0,0 0 0,0 0 0,-1 0 0,1 0 0,-2 0 0,-1 0 0,1 0 0,-1 0 0,-1 0 0,-1 0 0,1 0 0,-1 0 0,1 0 0,0 0-28,2 0 0,-1 0 1,1 0-1,1 0 1,-1 0-1,-1 0 1,1 0-1,-1 0 28,-1 0 0,-1 0 0,0 0 0,-1 0 0,1 0 0,-1 0 0,1 0 0,0 0 0,1 0 0,1 0 0,-1 0 0,0 0 0,1 0 0,-1 0 0,1 0 0,-1 0 0,0 0 0,-1 0 0,1 0 0,0 0 0,-1 0 0,1 0 0,-1 0 0,0 0 0,6 0 0,-1 0 0,0 0 0,0 0 0,0 0 0,0 0 0,-1 0 0,0 0 0,0 0 0,-1 0 0,0 0 0,1 0 0,-1 0 0,0 0 0,-1 0 0,-1 0 0,1 0 0,0 0 0,-1 0 0,1 0 0,-1 0 50,0 0 0,-1 0 0,1 0 0,-1 0 0,1 0 0,-1 0 0,1 0-50,-1 0 0,1 0 0,0 0 0,0 0 0,-1 0 0,1 0 0,0 0 0,1 0 0,0 0 0,1 0 0,-1 0 0,0 0 0,0 0 0,1 0 49,-1 0 1,0 0 0,0 0 0,0 0 0,0 0 0,1 0 0,-1 0-50,2 0 0,0 0 0,0 0 0,0 0 0,0 0 0,0 0 0,-1 0 0,-1 0 0,0 0 0,-1 0 0,1 0 0,-2 0 0,1 0 0,-1 0 0,3 0 0,0 0 0,-1 0 0,0 0 0,-1 0 0,0 0 251,-1 0 0,-1 0 1,0 0-1,-1 0 0,0 0 1,-1 0-252,1 0 0,-1 0 0,-1 0 0,0 0 0,1 0 305,0 0 0,1 0 1,-1 0-1,1 0 0,-2 0-305,3 0 0,0 0 0,-1 0 0,2 0 0,-3 0 0,1 0 0,1 0 0,-1 0 0,-2 0 0,0 0 0,-1 0 0,-1 0 0,2 0 449,4 0 0,2 0 0,-1 0 0,-2 0-449,1 0 0,-3 0 0,1 0 0,7 0 0,1 0 0,-2 0 0,-5 0 0,-1 0 0,-1 0 0,-5 0 0,0 0 0,-1 0 1015,0 0 1,-1 0 0,-1 0-1016,16 0 0,-2 0 0,-1 0 0,1 0 0,-9 0 0,3 0 0,-1 0 0,-4 0 0,-1 0 0,2 0 372,10 0 0,3 0 0,0 0-372,-2 0 0,0 0 0,1 0 0,-6 0 0,1 0 0,0 0 0,-1 0 0,7 0 0,-2 0 0,-1 0 0,-2 0 0,-1 0 0,-1 0 331,-3 0 0,0 0 0,-1 0-331,-3 0 0,0 0 0,0 0 0,5 0 0,0 1 0,1-2 0,-1-4 0,0-1 0,0 1 0,3 4 0,1 0 0,-3-1 0,-7-3 0,-2-1 0,1 2 284,3 2 0,0 3 0,-1 0-284,5-1 0,-2 0 196,5 0 1,1 0-197,-5 0 0,0 0 673,-5 0 1,0 0-674,0 0 0,-1 0 357,1 1 0,1-2-357,3-11 0,2 0 0,-7 9 0,1 3 0,0-3 0,11-9 0,0 1 0,-11 9 0,1 3 0,-3 0 108,0-1 0,-2 0-108,10 0 0,1 0 0,-3 0 0,2 0 0,-6 0 0,1 0 0,1 0-384,3 0 1,1 1 0,1-2 383,6-4 0,2-1 0,-1 1 0,-1 3 0,0 2 0,1-2-579,-3-1 1,2-1-1,0 0 1,1-1 578,-3 0 0,1-2 0,-1 1 0,3 1 0,-5 3 0,1 1 0,1 1 0,0-1 0,0-1-537,1-2 0,1-1 1,0 0-1,0 0 1,0 0 536,2 2 0,-1-1 0,1 1 0,0 0 0,0 1 0,-8 1 0,1 1 0,0 0 0,-1 0 0,1-1 0,-1-1 0,8-3 0,-1-2 0,1-1 0,-1 1 0,0 3 0,-3 2 0,1 2 0,-1 0 0,0 0 0,0-2 0,0-5 0,1-1 0,-1-2 0,-1 2 0,-2 1-294,2 5 0,-2 1 0,0 1 0,-1-2 294,-1-4 0,1-1 0,-2 1 0,0 1 0,4 4 0,-1 1 0,1 1 0,3-1 0,0 0 0,0 0 26,-2 0 0,0 0 0,0 0-26,2 0 0,0 0 0,-2 0 0,-8 0 0,-2 0 0,1 0 0,4 0 0,0 0 0,0 0 0,-4 0 0,0 0 0,-1 0 502,1 0 0,0 0 1,0 0-503,-1 0 0,0 0 0,-1 0 0,11 0 0,-2 0 1380,-2 0 0,-1 0-1380,-4 0 0,-2 0 782,-7 0 0,-1 0-782,0 0 0,-1 0 1014,12 0-1014,-9 0 400,3 0-400,-3 0 0,-7 0 0,3 0 0,-24-16 0,0-3 0,-11-9 0,-2-3 0,7-18 0,-6 20 0,1-3 0,9-7 0,4-4 0,-2 9 0,0-2 0,0-2-445,0-1 1,0-3 0,0-2 0,0 1 444,0-3 0,0-1 0,0 0 0,0-2-565,-1 4 0,1-1 0,-1-2 0,1 1 0,2 0 565,1 2 0,2-1 0,1 1 0,-1 0 0,-1 1 0,-2 0 0,-1 1 0,-1 0 0,1 0 0,1 0-287,2 1 1,1 0-1,1 1 1,-1 0-1,-1 1 287,-3-1 0,-1 0 0,-1 1 0,1 2-116,0-9 0,0 2 1,0 1 115,0 3 0,0 0 0,0 4 669,0 3 1,0 3-670,0-4 0,0 4 2746,0 9-2746,0-17 1804,0 35-1804,0-12 493,0 16-493,0 0 0,0-23 0,-24 17 0,18-18 0,-33 24 0,19 0 0,-23 0 0,6 0 0,5 0 0,-3 0 0,-4 0 0,-2 0 0,7 0 0,-3 0 0,0 0-332,-3 0 0,-1 0 0,-1 0 332,-6 0 0,-2 0 0,1 0-498,1 1 1,0-1-1,-1-1 498,9-2 0,0-1 0,0-1 0,1 2 0,-9 2 0,2 1 0,-1-3 0,11-3 0,0-3 0,-1 0 0,-1 1 0,-6 1 0,-2 1 0,0-1 0,0 0-690,-1-2 1,0 0 0,-1-1-1,-2 1 690,10 2 0,-2-1 0,0 1 0,-1 0 0,0 0 0,2 0 0,-6-2 0,0-1 0,1 1 0,0 1 0,-1 0 0,5 4 0,-1 0 0,0 1 0,0 1 0,1-2 0,0 0 0,-5-3 0,0-2 0,1 0 0,0 1 0,0 2-340,3 3 1,0 4-1,1 0 1,0-1-1,1-3 340,-6-5 0,1-4 0,0 1 0,1 3-159,1 4 1,0 4 0,0 0 0,1-2 158,3-4 0,0 0 0,0-1 0,-1 2 0,-2 3 0,-1 3 0,0 0 0,1-1 91,-6 1 1,1-1-1,0-1-91,-1-3 0,-1-3 0,2 2 0,6 4 0,1 0 0,1 0 0,-2-4 0,1-2 0,0 3 0,0 3 0,1 1 0,-2 1 0,-7-1 0,-1 0 0,2 0 0,4 0 0,2 0 0,-2 0 0,5 0 0,-2 0 0,-1 0 0,2 0 0,1 0 0,2 1 0,-1-1 0,1-1 0,-11-4 0,0-1 0,-1 1 0,6 4 0,0 0 0,-1 1 0,3-2 0,-3-2 0,2-1 0,-1-1 0,-6-2 0,-1-1 0,2 2 0,6 5 0,0 1 0,2-2 695,4-4 1,0-1 0,1 0-696,-1 1 0,1 2 0,2 1 957,-8 2 1,1 0-958,-4-6 0,2 0 882,14 8 0,-1 0-882,-12 0 0,0 0 1145,-8 0-1145,12 0 0,-3 0 0,-6 0 0,-2 0 0,10 0 0,-2 0 0,0 0 0,-3 0 0,1 0-232,6 0 0,0 0 0,0 0 232,-10 0 0,-2 0 0,1 0 0,2 0 0,0 0 0,-1 0 0,7 0 0,-2-1 0,0 1 0,0 1-517,-1 2 1,0 1-1,0 0 1,-1 1 516,-4 1 0,-2 1 0,0 0 0,-2 1 0,7-2 0,-1 2 0,-1-1 0,0 1 0,0 0-538,0 0 1,0 1 0,1 0-1,-2-1 1,0 1 537,3-2 0,-1 1 0,0-1 0,0 0 0,-1 0 0,0 0-468,-2 0 1,0-2 0,-1 1-1,0 0 1,0 0 0,0 1 467,7 0 0,0 0 0,0 0 0,0 1 0,-1-1 0,1 1 0,-1-1 0,-1 1 0,-1-1 0,0 1 0,0-1 0,0 1 0,0-1 0,1 1 0,-6 1 0,1 0 0,0-1 0,1 1 0,0 1 0,0 0 0,1 1 0,1 0 0,0 1 0,0 0 0,0 0 0,0-1 0,1-2 0,-1 1 0,1-1 0,-1-1 0,2 1 0,0 0-247,-4 2 1,2 0 0,0-1 0,0 1 0,1-1 246,-1 1 0,0 0 0,1 0 0,-1-1 0,1-2-59,2-2 1,1-2-1,0-1 1,0 1-1,0 1 59,-1 2 0,1 2 0,0 0 0,-1-1 0,1-2 0,0-3 0,-1-3 0,1-1 0,-1 1 0,1 2 0,0 3 0,-1 2 0,1 0 0,0 0 0,0-2 0,-1-2 0,1-3 0,-1 0 0,1 0 0,0 1 0,1 2 0,0-1 0,0 2 0,0-1 0,1 1 142,-9 2 0,1 0 0,0 1 1,-1-3-143,-1-1 0,-1-3 0,1 1 0,1 1 0,5 3 0,2 2 0,-1-1 0,0 0 0,-4-1 0,-1-1 0,0 0 0,0-1 0,2-2 0,0-1 0,0 1 0,0 0 0,3 3 0,1 1 0,-1-1 0,-1-1 0,4-2 0,-2-2 0,0 0 0,1 1 0,0 1 0,-7 4 0,2 2 0,-1 0 0,0-2 0,-2-3 0,0-1 0,0-1 0,0 3 0,8 0 0,-1 2 0,0 0 0,0 1 0,1-2 0,-6 1 0,1-1 0,-1 0 0,-1-1 0,3-2 0,-2 0 0,-1-1 0,1 0 0,1 2 0,3 0 0,1 2 0,1 0 0,-1-1 0,0-1 0,-3-1 0,-1 0 0,0-2 0,1 1 0,0-1 0,2 1 0,1 0 0,0 0 0,1 0 0,-1 0 0,1 0 0,0 0 0,1 0 0,-1 0 0,0 0 0,-1 0 0,0 0 0,-1 0 0,1 0 0,0 0 0,-1 0 0,1 0 0,0 0 0,0 0 0,-1 0 162,-2 0 1,-1 0-1,0 0 1,1 0-1,-1 0-162,3 0 0,0 0 0,1 0 0,-1 0 0,-1 0 0,-4 0 0,-1 0 0,0 0 0,0 0 0,1 0 0,4 0 0,1 0 0,1 0 0,-1 0 0,-1 0 0,3 1 0,-1-1 0,0 0 0,-1 1 0,1-2 0,1 0 0,-3-1 0,0-1 0,1-1 0,0 0 0,0 2 0,0 0 0,0 2 0,1 0 0,0-1 0,0 0 204,-7-2 1,1-1-1,1 0 1,1-1-205,-3-3 0,1-1 0,0 3 209,8 4 1,-2 2 0,1-1 0,1-2-210,-3-9 0,2-4 0,-2 4 0,-5 9 0,-2 3 0,1 0 406,6-5 0,1-2 1,2 3-407,3 3 0,1 1 0,1 1 0,0-1 0,1 0 0,1 0 1099,-8 1 1,2-2-1100,-5-10 0,-1-2 0,11 11 0,-1 1 0,0-2 0,-11-9 0,0 1 0,-1 9 0,-2 4 0,15-2 0,0 0 0,0 0 0,-7 0 0,-2 0 0,4 0 0,-2 0 0,2 0 0,-7 0 0,-1 0 0,9 0 0,-3 0 0,1 0 310,4 0 0,1 1 0,-2-2-310,-6-3 0,-1-3 0,0 2 0,2 4 0,0 0 0,0-1 0,-2-2 0,0-2 0,1 1 0,7-1 0,0 0 0,0 2 0,-4 2 0,-1 2 0,3-2 590,-5-5 0,1-2-590,9 1 0,-1 0 0,0 1 0,-15 4 0,1 0 0,3-9 0,-2 1 0,8 8 0,-2 4 0,2 1 0,-7-2 0,0 0 0,7 0 0,-2 0 0,1 0 0,4 0 0,1 0 0,-2 0 0,-3 0 0,-2 0 0,1 0 0,5 0 0,0 1 0,0-2-43,-4-4 0,0-1 0,1 1 43,3 3 0,0 2 0,0-2 0,-7-3 0,-2-1 0,1 1 0,3 4 0,-1 2 0,0-1 0,-2 1 0,0 0 0,1-3 0,2-5 0,0-2 0,-1 2 0,-6 4 0,-1 2 0,-1-1-577,2-6 0,1-1 1,-3 2 576,8 5 0,-2 3 0,-1 0 0,2-1 0,2 0 0,1 0 0,0 0 0,0 0-23,2 0 1,0 0 0,0 0 0,1 0 22,-10 0 0,1 0 0,0 0 0,1 0 0,1 0 0,2 0 0,7 0 0,2 0 0,-1 0 63,-4 0 1,0 0 0,4 0-64,5 0 0,1 0 298,-13 0 1,0 0-299,-8 0 900,18 0 1,1 0-901,-13 0 963,0 0-963,6 0 0,-6 0 0,13 0 0,1 0 0,-20 0 0,11 0 0,-1 0 0,12-1 0,-1 2 0,-17 11 0,-2 0 0,9-9 0,0 0 0,-10 9 0,0-1 0,5-9 0,0-4 0,-5 2 0,0 0 0,2 0 0,-1 0 0,13 0 0,-1 0 0,1 0 0,-11-1 0,1 2-146,10 4 1,0 1 0,-1-1 145,-1-3 0,0-2 0,0 2 0,-5 3 0,0 1 0,-1-1-421,-4-4 1,0-2 0,-1 1 420,2-1 0,-1 1 0,2 1 0,4-1 0,2 0 0,-2 0-258,-4-1 1,-2 1-1,3 1 258,8-1 0,2 0 0,-1 0-86,-2 0 1,0 0-1,0 0 86,2 0 0,-1 0 0,2 0 0,-7 0 0,0 0 0,6 0 0,-1 0 0,0 0 0,-10 0 0,-2 0 0,8 0 0,-2 0 0,1 0 0,-6 0 0,0 0 0,-2 0 0,0 0 0,4 0 0,2 0 193,10 0 0,-1 0-193,-5 0 0,0 0 609,2 0 0,1 0-609,3 0 0,0 0 415,1 0 0,1 0-415,-4-1 0,1 2 293,-8-1-293,0 0 0,0 0 0,0 0 0,1 0 0,-3 0 0,11 0 0,0 0 0,-8-2 0,-1 4 0,-1 9 0,-2 1 0,-3-9 0,-2 0-300,14 4 0,0 2 0,-3-2 300,-9 0 0,-3-2 0,0-1-452,7-3 0,1 0 1,-2 1 451,3 4 0,-3 2 0,1 1 0,0-1 0,-6 2 0,2-1 0,-2 0 0,12-4 0,-1 0 0,1 0 0,-1 1 0,-3 4 0,-1 1 0,1 0 0,2-3 0,-5-6 0,2-3 0,-1 3 0,3 6 0,-1 4 0,0-1 0,0-2 0,3-6 0,0-3 0,1 0 0,-1 3 0,-2 5 0,0 3 0,0 1 0,-1-4 0,2-5 0,-1-4 0,0 1 0,0 2 0,1 4 0,-1 2 0,1 1 0,1-1 0,-8 1 0,1 1 0,0-2-122,3 0 0,1-1 0,1 0 122,4 1 0,2 0 0,0 0 0,-11 0 0,2-1 0,10-5 0,1 0 0,-10 5 0,2 2 820,-1 7-820,-2-15 0,3 1 1389,15 14-1389,-2-14 0,-1-4 412,1 2-412,5 0 0,-1 0 0,7 0 0,12 0 0,-12 0 0,1 0 0,-13 0 0,-9 0 0,-6 0 0,0 0 0,5 0 0,5 0 0,0 0 0,-8 0 0,-2 0 0,3 0 0,34 0 0,-17 0 0,23 0 0,-16 0 0,12 0 0,-35 0 0,18 0 0,-22 0 0,-1 0 0,23 0 0,-18 0 0,19 0 0,0 0 0,-19 0 0,18 0 0,-7 0 0,-11 0 0,17 0 0,-21 0 0,24 0 0,-20 0 0,17 0 0,-5 0 0,-5 0 0,28 0 0,-35 0 0,33 0 0,-17 0 0,7 0 0,12 0 0,-12 0 0,16 0 0,-23 0 0,1 0 0,-21 0 0,0 24 0,6-18 0,-6 17 0,23-23 0,4 0 0,-7 0 0,17 0 0,-17 0 0,7 0 0,12 0 0,-12 0 0,16 0 0,0 0 0,0 0 0</inkml:trace>
+</inkml:ink>
+</file>
+
+<file path=ppt/ink/ink2.xml><?xml version="1.0" encoding="utf-8"?>
+<inkml:ink xmlns:inkml="http://www.w3.org/2003/InkML">
+  <inkml:definitions>
+    <inkml:context xml:id="ctx0">
+      <inkml:inkSource xml:id="inkSrc0">
+        <inkml:traceFormat>
+          <inkml:channel name="X" type="integer" min="-2.14748E9" max="2.14748E9" units="cm"/>
+          <inkml:channel name="Y" type="integer" min="-2.14748E9" max="2.14748E9" units="cm"/>
+          <inkml:channel name="F" type="integer" max="32767" units="dev"/>
+        </inkml:traceFormat>
+        <inkml:channelProperties>
+          <inkml:channelProperty channel="X" name="resolution" value="1000" units="1/cm"/>
+          <inkml:channelProperty channel="Y" name="resolution" value="1000" units="1/cm"/>
+          <inkml:channelProperty channel="F" name="resolution" value="0" units="1/dev"/>
+        </inkml:channelProperties>
+      </inkml:inkSource>
+      <inkml:timestamp xml:id="ts0" timeString="2026-03-30T20:40:02.282"/>
+    </inkml:context>
+    <inkml:brush xml:id="br0">
+      <inkml:brushProperty name="width" value="0.05292" units="cm"/>
+      <inkml:brushProperty name="height" value="0.05292" units="cm"/>
+      <inkml:brushProperty name="color" value="#FF0000"/>
+    </inkml:brush>
+  </inkml:definitions>
+  <inkml:trace contextRef="#ctx0" brushRef="#br0">10442 9560 24575,'35'0'0,"-1"0"0,9 0 0,2 0 0,-10 0 0,1 0 0,1 0 0,-1 0 0,0 0 0,0 0 0,12 0 0,0 0 0,-15 0 0,0 0 0,3 0-820,1 1 1,4-1 0,1 0 0,0-1 558,5-2 1,0-1 0,2-1 0,2 2-171,-7 1 1,2 2 0,1 0 0,1 1-1,-1-2 1,0-1 430,-5-2 0,0-1 0,0-1 0,0 0 0,0 1 0,0-1 0,3 1 0,1 1 0,0-1 0,0 1 0,-2-1 0,0 1 46,1-1 1,-2 1-1,0 0 1,-1 0-1,0-1-46,-1 0 0,-1 0 0,0 0 0,0 0 0,-1 2 0,10 1 0,0 2 0,-2 1 0,-2 0 0,1-1 0,-2 0 0,0 0-54,5 0 1,1 0 0,-6 0 53,-10 0 0,-4 0 858,2 0 0,-5 0-858,-7 0 3210,19 0-3210,-33 0 1664,33 0-1664,4 0 0,-5 0 0,5 0 0,-9 0 0,2 0 0,1 0 79,4 0 0,0 0 1,1 0-80,2 0 0,1 0 0,-3 0 0,3 0 0,-4 0 0,-5 0 0,-5 0 0,0 0 0,-27 0 0,12 0 0,-16 0 0</inkml:trace>
+  <inkml:trace contextRef="#ctx0" brushRef="#br0" timeOffset="2698">5415 13212 24575,'43'0'0,"-6"0"0,7 0 0,-25 0 0,20 0 0,-17 0 0,10 0 0,3 0 0,6 0 0,6 0 0,4 0 0,-17 0 0,0 0 0,0 0 0,3 0 0,-4 0 0,0 0 0,-1 0 0,9 1 0,0-2 0,-8-7 0,-1 0 0,0 6 0,1 0 0,9-5 0,-2-2 0,1-6 0,-7 13 0,-1 0 0,4-14 0,-12 15 0,1 2 0,0-1 0,1 0 0,1 2 0,-1-4 0,10-22 0,2 19 0,-19-19 0,-1 24 0,-3 0 0,-16 0 0</inkml:trace>
+  <inkml:trace contextRef="#ctx0" brushRef="#br0" timeOffset="32199">4745 11589 24575,'43'0'0,"-6"0"0,-9 0 0,3 0 0,-4 0 0,-5 0 0,2 0 0,-24 0 0,0 0 0,15 0 0,-11 0 0,12 0 0,7 0 0,-1 0 0,21 0 0,-23 0 0,19 0 0,-33 0 0,17 0 0,-23 0 0</inkml:trace>
+</inkml:ink>
+</file>
+
+<file path=ppt/ink/ink3.xml><?xml version="1.0" encoding="utf-8"?>
+<inkml:ink xmlns:inkml="http://www.w3.org/2003/InkML">
+  <inkml:definitions>
+    <inkml:context xml:id="ctx0">
+      <inkml:inkSource xml:id="inkSrc0">
+        <inkml:traceFormat>
+          <inkml:channel name="X" type="integer" min="-2.14748E9" max="2.14748E9" units="cm"/>
+          <inkml:channel name="Y" type="integer" min="-2.14748E9" max="2.14748E9" units="cm"/>
+          <inkml:channel name="F" type="integer" max="32767" units="dev"/>
+        </inkml:traceFormat>
+        <inkml:channelProperties>
+          <inkml:channelProperty channel="X" name="resolution" value="1000" units="1/cm"/>
+          <inkml:channelProperty channel="Y" name="resolution" value="1000" units="1/cm"/>
+          <inkml:channelProperty channel="F" name="resolution" value="0" units="1/dev"/>
+        </inkml:channelProperties>
+      </inkml:inkSource>
+      <inkml:timestamp xml:id="ts0" timeString="2026-03-30T20:41:42.915"/>
+    </inkml:context>
+    <inkml:brush xml:id="br0">
+      <inkml:brushProperty name="width" value="0.05292" units="cm"/>
+      <inkml:brushProperty name="height" value="0.05292" units="cm"/>
+      <inkml:brushProperty name="color" value="#FF0000"/>
+    </inkml:brush>
+  </inkml:definitions>
+  <inkml:trace contextRef="#ctx0" brushRef="#br0">5574 13141 24575,'34'0'0,"0"0"0,9 0 0,3 0 0,-12 1 0,2-1 0,1-1-689,9-5 0,1-3 0,0 0 689,-5 2 0,0 0 0,1 0 0,-3 1 0,1-1 0,1 1 0,-2-3 0,4-4 0,-2-2 0,1 4 0,1 8 0,1 3 0,-3-3 119,-6-4 1,-1-3-1,-2 4-119,8 6 0,-1 0 206,-5-8 1,0 0-207,4 6 0,-1 0 0,-14-6 0,1 1 0,4 6 0,0 2 1048,14-1-1048,-5 0 248,-11 0-248,5 0 0,-29 0 0,13 0 0</inkml:trace>
+</inkml:ink>
+</file>
+
+<file path=ppt/ink/ink4.xml><?xml version="1.0" encoding="utf-8"?>
+<inkml:ink xmlns:inkml="http://www.w3.org/2003/InkML">
+  <inkml:definitions>
+    <inkml:context xml:id="ctx0">
+      <inkml:inkSource xml:id="inkSrc0">
+        <inkml:traceFormat>
+          <inkml:channel name="X" type="integer" min="-2.14748E9" max="2.14748E9" units="cm"/>
+          <inkml:channel name="Y" type="integer" min="-2.14748E9" max="2.14748E9" units="cm"/>
+          <inkml:channel name="F" type="integer" max="32767" units="dev"/>
+        </inkml:traceFormat>
+        <inkml:channelProperties>
+          <inkml:channelProperty channel="X" name="resolution" value="1000" units="1/cm"/>
+          <inkml:channelProperty channel="Y" name="resolution" value="1000" units="1/cm"/>
+          <inkml:channelProperty channel="F" name="resolution" value="0" units="1/dev"/>
+        </inkml:channelProperties>
+      </inkml:inkSource>
+      <inkml:timestamp xml:id="ts0" timeString="2026-03-30T20:41:53.067"/>
+    </inkml:context>
+    <inkml:brush xml:id="br0">
+      <inkml:brushProperty name="width" value="0.05292" units="cm"/>
+      <inkml:brushProperty name="height" value="0.05292" units="cm"/>
+      <inkml:brushProperty name="color" value="#FF0000"/>
+    </inkml:brush>
+  </inkml:definitions>
+  <inkml:trace contextRef="#ctx0" brushRef="#br0">4780 15152 24575,'31'0'0,"-1"0"0,4 0 0,2 0 0,12 0 0,0 0 0,-2 0 0,1 0 0,-12 0 0,0 0 0,-2 0 0,1 0 0,-3 0 0,4 0 0,-3 0 0,5 0 0,6 0 0,-23 0 0,-5 0 0,-15 0 0</inkml:trace>
+</inkml:ink>
+</file>
+
+<file path=ppt/ink/ink5.xml><?xml version="1.0" encoding="utf-8"?>
+<inkml:ink xmlns:inkml="http://www.w3.org/2003/InkML">
+  <inkml:definitions>
+    <inkml:context xml:id="ctx0">
+      <inkml:inkSource xml:id="inkSrc0">
+        <inkml:traceFormat>
+          <inkml:channel name="X" type="integer" min="-2.14748E9" max="2.14748E9" units="cm"/>
+          <inkml:channel name="Y" type="integer" min="-2.14748E9" max="2.14748E9" units="cm"/>
+          <inkml:channel name="F" type="integer" max="32767" units="dev"/>
+        </inkml:traceFormat>
+        <inkml:channelProperties>
+          <inkml:channelProperty channel="X" name="resolution" value="1000" units="1/cm"/>
+          <inkml:channelProperty channel="Y" name="resolution" value="1000" units="1/cm"/>
+          <inkml:channelProperty channel="F" name="resolution" value="0" units="1/dev"/>
+        </inkml:channelProperties>
+      </inkml:inkSource>
+      <inkml:timestamp xml:id="ts0" timeString="2026-03-30T20:42:05.182"/>
+    </inkml:context>
+    <inkml:brush xml:id="br0">
+      <inkml:brushProperty name="width" value="0.05292" units="cm"/>
+      <inkml:brushProperty name="height" value="0.05292" units="cm"/>
+      <inkml:brushProperty name="color" value="#FF0000"/>
+    </inkml:brush>
+  </inkml:definitions>
+  <inkml:trace contextRef="#ctx0" brushRef="#br0">1588 15610 8191,'45'0'0,"-7"0"0,6 0 975,1 0 0,4 0 0,4 0-975,-14 0 0,1 0 0,2 0 0,2 0 0,1 0 0,1 0 0,3 0 0,1 0 0,1 0 0,0 0 0,-1 0-3,-6 0 0,0 0 1,0 0-1,1 0 0,-1 0 1,1 0-1,1 0 3,-2 0 0,0 0 0,1 0 0,0 0 0,1 0 0,-1 0 0,0 0 0,0 0 0,4 0 0,0 0 0,-1 0 0,0 0 0,1 0 0,0 0 0,0 0 0,-5 0 0,1 0 0,0 0 0,0 0 0,0 0 0,0 0 0,0 0 0,-1 0 0,1 0 0,-1 0 0,0 0 0,0 0 0,0 0 0,0 0 0,-1 0 0,0 0 0,4 1 0,0-1 0,-1 0 0,0 1 0,0-1 0,0-1 0,0 0 101,-2 0 0,1-1 0,0-1 0,0 0 0,-2 1 1,0-1-1,-1 2-101,9 0 0,-2 0 0,-1 1 0,-2-1 0,-1 0 760,4-3 1,-3 0 0,0-1 0,-2 2-761,7 2 0,-2 2 0,-2-1 462,-10 0 0,-1 0 1,-2 0-463,15 0 0,-2 0 0,-2 0 0,-3 0 1638,-10 0 0,0 0-1398,7 0 1,-1 0 1251,-10 0 0,-1 0-1492,0 0 0,-1 0 1361,1 0-1361,-11 0 0,-16 0 0,0 0 0</inkml:trace>
+  <inkml:trace contextRef="#ctx0" brushRef="#br0" timeOffset="3714">2134 12806 24575,'41'0'0,"1"0"0,-1 0 0,-4 0 0,0 0 0,3 0 0,3 0 0,-3 0 0,4 0 0,2 0 0,1 0 0,0 0 0,-1 0-547,0 0 1,1 0 0,-1 0 0,1 0 0,0 0 0,0 0 77,-3 0 1,-1 0 0,1 0 0,1 0 0,-1 0 0,0 0 0,0 0 365,6 0 1,0 0 0,0 0 0,0 0 0,-1 0 0,0 0 102,-3 0 0,-1 0 0,-1 0 0,1 0 0,-1 0 0,0 0-118,-1 0 1,0 0 0,0 0 0,0 0 0,-1 0 0,-1 0 117,6 0 0,-1 0 0,0 0 0,-1 0 0,-1 0 89,4 0 0,-1 0 0,0 0 0,-1 0-89,-2 0 0,0 0 0,0 0 0,-2 0-264,6 0 1,-1 0-1,-1 0 264,-1 1 0,-2 0 0,1-3 0,-3-5 0,0-2 0,0 1 0,0 6 0,0 1 0,0-2 837,1-4 0,-1-2 0,0 2-837,-4 5 0,-1 3 0,-1 0 1174,6-1 1,-2 0-1175,-3 0 0,-5 0 0,-10 0 0,3 0 0</inkml:trace>
+  <inkml:trace contextRef="#ctx0" brushRef="#br0" timeOffset="5215">10830 12965 24575,'38'0'0,"-1"0"0,-3 0 0,2 0 0,2 0 0,3 0 0,3 0 0,0 0-497,5 0 1,1 0 0,-2 0 496,-11 0 0,-2 0 0,1 0 0,4 0 0,0 0 0,-1 0 0,8 0 0,-2 0 242,-4 0 0,-1 0-242,-5 0 0,-4 0 246,7 0-246,-11 0 0,-11 0 0,-16 0 0</inkml:trace>
+  <inkml:trace contextRef="#ctx0" brushRef="#br0" timeOffset="6583">10160 15187 24575,'35'0'0,"-1"0"0,1 0 0,5 0 0,1 0 0,1 0 0,-5 0 0,1 0 0,0 0 0,0 0-529,2 0 1,1 0 0,0 0-1,-2 0 529,8 0 0,-2 0 0,-2 0 0,9 0 0,-8 0 679,-1 0-679,-27 24 0,-16-19 0,0 19 0</inkml:trace>
+</inkml:ink>
+</file>
+
+<file path=ppt/ink/ink6.xml><?xml version="1.0" encoding="utf-8"?>
+<inkml:ink xmlns:inkml="http://www.w3.org/2003/InkML">
+  <inkml:definitions>
+    <inkml:context xml:id="ctx0">
+      <inkml:inkSource xml:id="inkSrc0">
+        <inkml:traceFormat>
+          <inkml:channel name="X" type="integer" min="-2.14748E9" max="2.14748E9" units="cm"/>
+          <inkml:channel name="Y" type="integer" min="-2.14748E9" max="2.14748E9" units="cm"/>
+          <inkml:channel name="F" type="integer" max="32767" units="dev"/>
+        </inkml:traceFormat>
+        <inkml:channelProperties>
+          <inkml:channelProperty channel="X" name="resolution" value="1000" units="1/cm"/>
+          <inkml:channelProperty channel="Y" name="resolution" value="1000" units="1/cm"/>
+          <inkml:channelProperty channel="F" name="resolution" value="0" units="1/dev"/>
+        </inkml:channelProperties>
+      </inkml:inkSource>
+      <inkml:timestamp xml:id="ts0" timeString="2026-03-30T20:51:23.863"/>
+    </inkml:context>
+    <inkml:brush xml:id="br0">
+      <inkml:brushProperty name="width" value="0.05292" units="cm"/>
+      <inkml:brushProperty name="height" value="0.05292" units="cm"/>
+      <inkml:brushProperty name="color" value="#FF0000"/>
+    </inkml:brush>
+  </inkml:definitions>
+  <inkml:trace contextRef="#ctx0" brushRef="#br0">25047 13511 24575,'0'30'0,"0"-1"0,1 3 0,-2 1 0,-6 10 0,-1 2 0,5-5 0,2 0 0,-4-4 0,-2 2 0,3-2 0,3 4 0,2-1 0,-1 9 0,0-2 0,0-19 0,0-1 0,0 17 0,0 0 0,0-22 0,0 19 0,0-37 0,0 37 0,0-34 0,0 17 0,0-23 0,0 16 0,0-12 0,0 27 0,0 12 0,0-2 0,0 0 0,0 1 0,0 7 0,0-19 0,0 0 0,0 13 0,0-23 0,0-4 0,0 7 0,0-17 0,0 18 0,0-24 0,0 15 0,0-11 0,-2 21 0,4 5 0,14-4 0,-15 7 0,2 0 0,12-11 0,-15 17 0,0-35 0,0 12 0,0-1 0,0-11 0,0 12 0,0-16 0,0 0 0,0 23 0,0-17 0,0 18 0,0-24 0,0 0 0,24 15 0,-18-11 0,17 36 0,-23-35 0,0 35 0,0-36 0,0 11 0,16 1 0,-12-12 0,11 35 0,-15-33 0,0 17 0,0-7 0,0-12 0,0 12 0,0-16 0,0 15 0,0-11 0,0 12 0,0 8 0,0-19 0,0 19 0,0-24 0,0 16 0,0-12 0,0 11 0,0-15 0,0 24 0,0-18 0,0 17 0</inkml:trace>
+</inkml:ink>
+</file>
+
+<file path=ppt/ink/ink7.xml><?xml version="1.0" encoding="utf-8"?>
+<inkml:ink xmlns:inkml="http://www.w3.org/2003/InkML">
+  <inkml:definitions>
+    <inkml:context xml:id="ctx0">
+      <inkml:inkSource xml:id="inkSrc0">
+        <inkml:traceFormat>
+          <inkml:channel name="X" type="integer" min="-2.14748E9" max="2.14748E9" units="cm"/>
+          <inkml:channel name="Y" type="integer" min="-2.14748E9" max="2.14748E9" units="cm"/>
+          <inkml:channel name="F" type="integer" max="32767" units="dev"/>
+        </inkml:traceFormat>
+        <inkml:channelProperties>
+          <inkml:channelProperty channel="X" name="resolution" value="1000" units="1/cm"/>
+          <inkml:channelProperty channel="Y" name="resolution" value="1000" units="1/cm"/>
+          <inkml:channelProperty channel="F" name="resolution" value="0" units="1/dev"/>
+        </inkml:channelProperties>
+      </inkml:inkSource>
+      <inkml:timestamp xml:id="ts0" timeString="2026-03-30T20:53:29.412"/>
+    </inkml:context>
+    <inkml:brush xml:id="br0">
+      <inkml:brushProperty name="width" value="0.05292" units="cm"/>
+      <inkml:brushProperty name="height" value="0.05292" units="cm"/>
+      <inkml:brushProperty name="color" value="#FF0000"/>
+    </inkml:brush>
+  </inkml:definitions>
+  <inkml:trace contextRef="#ctx0" brushRef="#br0">1552 10654 24575,'43'0'0,"-6"0"0,3 0 0,-3 0 0,2 0 0,0 0 0,2 0 0,-1 0 0,6 0 0,0 0 0,2 0 0,0 0 0,-14 0 0,0 0 0,0 0 0,8 1 0,0-2 0,-8-4 0,2-1 0,-2 1 0,11 5 0,-2-4 0,2-15 0,-2-1 0,-9 17 0,-3 0 0,12-20 0,-27 23 0,0 0 0,-13 0 0,13 0 0</inkml:trace>
+  <inkml:trace contextRef="#ctx0" brushRef="#br0" timeOffset="7917">3898 10566 24575,'31'0'0,"-1"0"0,4 0 0,3 0 0,9 0 0,4 0-297,-15 0 1,1 0 0,0 0 296,1 0 0,-1 0 0,-1 0 0,12 0 0,-6 0 292,4 0-292,-5 0 148,-36 0-148,19 0 0,8 0 0,11 0 0,-10 0 0,6 0 0,1 0 0,0 0 0,0 1 0,1-2-208,4-4 1,2-1-1,-1 1 208,2 3 0,0 2 0,-2-2 0,-7-3 0,-3-1 0,0 1 0,12 5 0,-6 0 0,4 0 0,-5 0 0,-37 0 0,13 0 0,-16 16 1072,0-12-1072,0 12 0,0-16 0,0 0 0</inkml:trace>
+</inkml:ink>
+</file>
+
+<file path=ppt/ink/ink8.xml><?xml version="1.0" encoding="utf-8"?>
+<inkml:ink xmlns:inkml="http://www.w3.org/2003/InkML">
+  <inkml:definitions>
+    <inkml:context xml:id="ctx0">
+      <inkml:inkSource xml:id="inkSrc0">
+        <inkml:traceFormat>
+          <inkml:channel name="X" type="integer" min="-2.14748E9" max="2.14748E9" units="cm"/>
+          <inkml:channel name="Y" type="integer" min="-2.14748E9" max="2.14748E9" units="cm"/>
+          <inkml:channel name="F" type="integer" max="32767" units="dev"/>
+        </inkml:traceFormat>
+        <inkml:channelProperties>
+          <inkml:channelProperty channel="X" name="resolution" value="1000" units="1/cm"/>
+          <inkml:channelProperty channel="Y" name="resolution" value="1000" units="1/cm"/>
+          <inkml:channelProperty channel="F" name="resolution" value="0" units="1/dev"/>
+        </inkml:channelProperties>
+      </inkml:inkSource>
+      <inkml:timestamp xml:id="ts0" timeString="2026-03-30T20:54:23.680"/>
+    </inkml:context>
+    <inkml:brush xml:id="br0">
+      <inkml:brushProperty name="width" value="0.05292" units="cm"/>
+      <inkml:brushProperty name="height" value="0.05292" units="cm"/>
+      <inkml:brushProperty name="color" value="#FF0000"/>
+    </inkml:brush>
+  </inkml:definitions>
+  <inkml:trace contextRef="#ctx0" brushRef="#br0">1764 12541 24575,'43'0'0,"-18"0"0,3 0 0,18 0 0,2 0 0,-9 0 0,0 0 0,9 0 0,-2 0 0,-9 0 0,-5 0 0,-1 0 0,-1 0 0,-5 0 0,-19 0 0,33 0 0,-11 0 0,9 0 0,-5 1 0,3-2 0,4-6 0,2-1 0,5 6 0,0 0 0,-5-5 0,-1-2 0,2 0 0,-2 2 0,1 3 0,-8-4 0,1 1 0,3 7 0,-10 0 0,5 0 0,-28 0 0,11 0 0</inkml:trace>
+  <inkml:trace contextRef="#ctx0" brushRef="#br0" timeOffset="6549">4110 12541 24575,'50'0'0,"0"0"0,-12 0 0,1 0 0,3 0 0,0 0 0,2 0 0,2 0 0,-1 0-820,-1 0 1,0 0 0,1 0 0,0 0 613,4 0 1,1 0 0,1 0-1,-1 0 206,-1 0 0,0 0 0,0 0 0,0 0 0,-1 0 0,-1 0 0,0 0 0,-1 0-133,-3 0 0,-2 0 0,0 0 0,1 0 133,-1 0 0,0 0 0,0 0 0,-2 0 0,5 0 0,-1 0 0,0 0 159,6 0 1,0 0 0,0 0-160,-7 0 0,-2 0 0,1 0 0,0 0 0,0 0 0,1 0 0,2 0 0,1 0 0,-3 0 0,2 0 0,-2 0 0,3 0 0,-7 0 0,-19 0 1928,20 0-1928,-33 0 1532,18 0-1532,-24 0 692,0 0-692,0 24 0,0-18 0,15 17 0,-11-23 0,12 0 0,-16 0 0,0 16 0,0-12 0,0 11 0,0-15 0,0 0 0,0 16 0,0-12 0,0 12 0</inkml:trace>
+  <inkml:trace contextRef="#ctx0" brushRef="#br0" timeOffset="8265">9155 12665 24575,'-45'0'0,"1"0"0,1 0 0,-2 0 0,11 0 0,-1 0 0,0 0 0,-11 0 0,0 0 0,-3 0 0,2 0 0,11 0 0,2 0 0,6 0 0,3 0 0,-3 0 0,-3 0 0,27 0 0,-12 0 0,16-16 0,-39 12 0,16-3 0,-3-2 0,-6 3 0,-4 1 0,0 1 0,-11 2 0,2 0 0,3-6 0,4 0 0,-5 8 0,3 0 0,58 0 0,-36 0 0,42 0 0</inkml:trace>
+</inkml:ink>
+</file>
+
+<file path=ppt/ink/ink9.xml><?xml version="1.0" encoding="utf-8"?>
+<inkml:ink xmlns:inkml="http://www.w3.org/2003/InkML">
+  <inkml:definitions>
+    <inkml:context xml:id="ctx0">
+      <inkml:inkSource xml:id="inkSrc0">
+        <inkml:traceFormat>
+          <inkml:channel name="X" type="integer" min="-2.14748E9" max="2.14748E9" units="cm"/>
+          <inkml:channel name="Y" type="integer" min="-2.14748E9" max="2.14748E9" units="cm"/>
+          <inkml:channel name="F" type="integer" max="32767" units="dev"/>
+        </inkml:traceFormat>
+        <inkml:channelProperties>
+          <inkml:channelProperty channel="X" name="resolution" value="1000" units="1/cm"/>
+          <inkml:channelProperty channel="Y" name="resolution" value="1000" units="1/cm"/>
+          <inkml:channelProperty channel="F" name="resolution" value="0" units="1/dev"/>
+        </inkml:channelProperties>
+      </inkml:inkSource>
+      <inkml:timestamp xml:id="ts0" timeString="2026-03-30T20:54:49.361"/>
+    </inkml:context>
+    <inkml:brush xml:id="br0">
+      <inkml:brushProperty name="width" value="0.05292" units="cm"/>
+      <inkml:brushProperty name="height" value="0.05292" units="cm"/>
+      <inkml:brushProperty name="color" value="#FF0000"/>
+    </inkml:brush>
+  </inkml:definitions>
+  <inkml:trace contextRef="#ctx0" brushRef="#br0">4780 14640 24575,'45'0'0,"-2"0"0,0 0 0,-5 0 0,-12 0 0,-1 0 0,-4 0 0,18 0 0,-35 0 0,28 0 0,-5 0 0,-2 0 0,3 0 0,6 0 0,3 0 0,3 0 0,0 0 0,-8 0 0,1 0 0,10 0 0,-4 0 0,-14 0 0,5-2 0,-5 4 0,-21 22 0,35-18 0,-33 17 0,18-23 0</inkml:trace>
+</inkml:ink>
 </file>
 
 <file path=ppt/slideLayouts/slideLayout1.xml><?xml version="1.0" encoding="utf-8"?>
@@ -810,7 +1177,7 @@
           <a:p>
             <a:fld id="{E80C50CD-E178-4744-9B35-B2F624D6C5E9}" type="datetimeFigureOut">
               <a:rPr lang="en-US" smtClean="0"/>
-              <a:t>3/25/26</a:t>
+              <a:t>3/30/26</a:t>
             </a:fld>
             <a:endParaRPr lang="en-US"/>
           </a:p>
@@ -1008,7 +1375,7 @@
           <a:p>
             <a:fld id="{E80C50CD-E178-4744-9B35-B2F624D6C5E9}" type="datetimeFigureOut">
               <a:rPr lang="en-US" smtClean="0"/>
-              <a:t>3/25/26</a:t>
+              <a:t>3/30/26</a:t>
             </a:fld>
             <a:endParaRPr lang="en-US"/>
           </a:p>
@@ -1216,7 +1583,7 @@
           <a:p>
             <a:fld id="{E80C50CD-E178-4744-9B35-B2F624D6C5E9}" type="datetimeFigureOut">
               <a:rPr lang="en-US" smtClean="0"/>
-              <a:t>3/25/26</a:t>
+              <a:t>3/30/26</a:t>
             </a:fld>
             <a:endParaRPr lang="en-US"/>
           </a:p>
@@ -1466,7 +1833,7 @@
           <a:p>
             <a:fld id="{E80C50CD-E178-4744-9B35-B2F624D6C5E9}" type="datetimeFigureOut">
               <a:rPr lang="en-US" smtClean="0"/>
-              <a:t>3/25/26</a:t>
+              <a:t>3/30/26</a:t>
             </a:fld>
             <a:endParaRPr lang="en-US"/>
           </a:p>
@@ -1745,7 +2112,7 @@
           <a:p>
             <a:fld id="{E80C50CD-E178-4744-9B35-B2F624D6C5E9}" type="datetimeFigureOut">
               <a:rPr lang="en-US" smtClean="0"/>
-              <a:t>3/25/26</a:t>
+              <a:t>3/30/26</a:t>
             </a:fld>
             <a:endParaRPr lang="en-US"/>
           </a:p>
@@ -2062,7 +2429,7 @@
           <a:p>
             <a:fld id="{E80C50CD-E178-4744-9B35-B2F624D6C5E9}" type="datetimeFigureOut">
               <a:rPr lang="en-US" smtClean="0"/>
-              <a:t>3/25/26</a:t>
+              <a:t>3/30/26</a:t>
             </a:fld>
             <a:endParaRPr lang="en-US"/>
           </a:p>
@@ -2478,7 +2845,7 @@
           <a:p>
             <a:fld id="{E80C50CD-E178-4744-9B35-B2F624D6C5E9}" type="datetimeFigureOut">
               <a:rPr lang="en-US" smtClean="0"/>
-              <a:t>3/25/26</a:t>
+              <a:t>3/30/26</a:t>
             </a:fld>
             <a:endParaRPr lang="en-US"/>
           </a:p>
@@ -2619,7 +2986,7 @@
           <a:p>
             <a:fld id="{E80C50CD-E178-4744-9B35-B2F624D6C5E9}" type="datetimeFigureOut">
               <a:rPr lang="en-US" smtClean="0"/>
-              <a:t>3/25/26</a:t>
+              <a:t>3/30/26</a:t>
             </a:fld>
             <a:endParaRPr lang="en-US"/>
           </a:p>
@@ -2732,7 +3099,7 @@
           <a:p>
             <a:fld id="{E80C50CD-E178-4744-9B35-B2F624D6C5E9}" type="datetimeFigureOut">
               <a:rPr lang="en-US" smtClean="0"/>
-              <a:t>3/25/26</a:t>
+              <a:t>3/30/26</a:t>
             </a:fld>
             <a:endParaRPr lang="en-US"/>
           </a:p>
@@ -3049,7 +3416,7 @@
           <a:p>
             <a:fld id="{E80C50CD-E178-4744-9B35-B2F624D6C5E9}" type="datetimeFigureOut">
               <a:rPr lang="en-US" smtClean="0"/>
-              <a:t>3/25/26</a:t>
+              <a:t>3/30/26</a:t>
             </a:fld>
             <a:endParaRPr lang="en-US"/>
           </a:p>
@@ -3341,7 +3708,7 @@
           <a:p>
             <a:fld id="{E80C50CD-E178-4744-9B35-B2F624D6C5E9}" type="datetimeFigureOut">
               <a:rPr lang="en-US" smtClean="0"/>
-              <a:t>3/25/26</a:t>
+              <a:t>3/30/26</a:t>
             </a:fld>
             <a:endParaRPr lang="en-US"/>
           </a:p>
@@ -3581,7 +3948,7 @@
             <a:fld id="{E80C50CD-E178-4744-9B35-B2F624D6C5E9}" type="datetimeFigureOut">
               <a:rPr lang="en-US" smtClean="0"/>
               <a:pPr/>
-              <a:t>3/25/26</a:t>
+              <a:t>3/30/26</a:t>
             </a:fld>
             <a:endParaRPr lang="en-US"/>
           </a:p>
@@ -5345,8 +5712,8 @@
           </a:p>
         </p:txBody>
       </p:sp>
-      <mc:AlternateContent xmlns:mc="http://schemas.openxmlformats.org/markup-compatibility/2006">
-        <mc:Choice xmlns:a14="http://schemas.microsoft.com/office/drawing/2010/main" Requires="a14">
+      <mc:AlternateContent xmlns:mc="http://schemas.openxmlformats.org/markup-compatibility/2006" xmlns:a14="http://schemas.microsoft.com/office/drawing/2010/main">
+        <mc:Choice Requires="a14">
           <p:sp>
             <p:nvSpPr>
               <p:cNvPr id="3" name="Content Placeholder 2">
@@ -6249,7 +6616,7 @@
             </p:txBody>
           </p:sp>
         </mc:Choice>
-        <mc:Fallback>
+        <mc:Fallback xmlns="">
           <p:sp>
             <p:nvSpPr>
               <p:cNvPr id="3" name="Content Placeholder 2">
@@ -6291,6 +6658,57 @@
               </a:p>
             </p:txBody>
           </p:sp>
+        </mc:Fallback>
+      </mc:AlternateContent>
+      <mc:AlternateContent xmlns:mc="http://schemas.openxmlformats.org/markup-compatibility/2006">
+        <mc:Choice xmlns:p14="http://schemas.microsoft.com/office/powerpoint/2010/main" Requires="p14">
+          <p:contentPart p14:bwMode="auto" r:id="rId3">
+            <p14:nvContentPartPr>
+              <p14:cNvPr id="4" name="Ink 3">
+                <a:extLst>
+                  <a:ext uri="{FF2B5EF4-FFF2-40B4-BE49-F238E27FC236}">
+                    <a16:creationId xmlns:a16="http://schemas.microsoft.com/office/drawing/2014/main" id="{8F393F8E-8C9E-1F10-D285-9D8B977FB176}"/>
+                  </a:ext>
+                </a:extLst>
+              </p14:cNvPr>
+              <p14:cNvContentPartPr/>
+              <p14:nvPr/>
+            </p14:nvContentPartPr>
+            <p14:xfrm>
+              <a:off x="1104840" y="4349880"/>
+              <a:ext cx="514800" cy="32400"/>
+            </p14:xfrm>
+          </p:contentPart>
+        </mc:Choice>
+        <mc:Fallback>
+          <p:pic>
+            <p:nvPicPr>
+              <p:cNvPr id="4" name="Ink 3">
+                <a:extLst>
+                  <a:ext uri="{FF2B5EF4-FFF2-40B4-BE49-F238E27FC236}">
+                    <a16:creationId xmlns:a16="http://schemas.microsoft.com/office/drawing/2014/main" id="{8F393F8E-8C9E-1F10-D285-9D8B977FB176}"/>
+                  </a:ext>
+                </a:extLst>
+              </p:cNvPr>
+              <p:cNvPicPr/>
+              <p:nvPr/>
+            </p:nvPicPr>
+            <p:blipFill>
+              <a:blip r:embed="rId4"/>
+              <a:stretch>
+                <a:fillRect/>
+              </a:stretch>
+            </p:blipFill>
+            <p:spPr>
+              <a:xfrm>
+                <a:off x="1095480" y="4340520"/>
+                <a:ext cx="533520" cy="51120"/>
+              </a:xfrm>
+              <a:prstGeom prst="rect">
+                <a:avLst/>
+              </a:prstGeom>
+            </p:spPr>
+          </p:pic>
         </mc:Fallback>
       </mc:AlternateContent>
     </p:spTree>
@@ -6355,8 +6773,8 @@
           </a:p>
         </p:txBody>
       </p:sp>
-      <mc:AlternateContent xmlns:mc="http://schemas.openxmlformats.org/markup-compatibility/2006">
-        <mc:Choice xmlns:a14="http://schemas.microsoft.com/office/drawing/2010/main" Requires="a14">
+      <mc:AlternateContent xmlns:mc="http://schemas.openxmlformats.org/markup-compatibility/2006" xmlns:a14="http://schemas.microsoft.com/office/drawing/2010/main">
+        <mc:Choice Requires="a14">
           <p:sp>
             <p:nvSpPr>
               <p:cNvPr id="3" name="Content Placeholder 2">
@@ -6529,7 +6947,7 @@
             </p:txBody>
           </p:sp>
         </mc:Choice>
-        <mc:Fallback>
+        <mc:Fallback xmlns="">
           <p:sp>
             <p:nvSpPr>
               <p:cNvPr id="3" name="Content Placeholder 2">
@@ -6567,6 +6985,57 @@
               </a:p>
             </p:txBody>
           </p:sp>
+        </mc:Fallback>
+      </mc:AlternateContent>
+      <mc:AlternateContent xmlns:mc="http://schemas.openxmlformats.org/markup-compatibility/2006">
+        <mc:Choice xmlns:p14="http://schemas.microsoft.com/office/powerpoint/2010/main" Requires="p14">
+          <p:contentPart p14:bwMode="auto" r:id="rId3">
+            <p14:nvContentPartPr>
+              <p14:cNvPr id="4" name="Ink 3">
+                <a:extLst>
+                  <a:ext uri="{FF2B5EF4-FFF2-40B4-BE49-F238E27FC236}">
+                    <a16:creationId xmlns:a16="http://schemas.microsoft.com/office/drawing/2014/main" id="{73B5DED4-5C3A-2560-09BD-2F9CD09382BD}"/>
+                  </a:ext>
+                </a:extLst>
+              </p14:cNvPr>
+              <p14:cNvContentPartPr/>
+              <p14:nvPr/>
+            </p14:nvContentPartPr>
+            <p14:xfrm>
+              <a:off x="1708200" y="3396600"/>
+              <a:ext cx="3321360" cy="1360440"/>
+            </p14:xfrm>
+          </p:contentPart>
+        </mc:Choice>
+        <mc:Fallback>
+          <p:pic>
+            <p:nvPicPr>
+              <p:cNvPr id="4" name="Ink 3">
+                <a:extLst>
+                  <a:ext uri="{FF2B5EF4-FFF2-40B4-BE49-F238E27FC236}">
+                    <a16:creationId xmlns:a16="http://schemas.microsoft.com/office/drawing/2014/main" id="{73B5DED4-5C3A-2560-09BD-2F9CD09382BD}"/>
+                  </a:ext>
+                </a:extLst>
+              </p:cNvPr>
+              <p:cNvPicPr/>
+              <p:nvPr/>
+            </p:nvPicPr>
+            <p:blipFill>
+              <a:blip r:embed="rId4"/>
+              <a:stretch>
+                <a:fillRect/>
+              </a:stretch>
+            </p:blipFill>
+            <p:spPr>
+              <a:xfrm>
+                <a:off x="1698840" y="3387240"/>
+                <a:ext cx="3340080" cy="1379160"/>
+              </a:xfrm>
+              <a:prstGeom prst="rect">
+                <a:avLst/>
+              </a:prstGeom>
+            </p:spPr>
+          </p:pic>
         </mc:Fallback>
       </mc:AlternateContent>
     </p:spTree>
@@ -6637,8 +7106,8 @@
           </a:p>
         </p:txBody>
       </p:sp>
-      <mc:AlternateContent xmlns:mc="http://schemas.openxmlformats.org/markup-compatibility/2006">
-        <mc:Choice xmlns:a14="http://schemas.microsoft.com/office/drawing/2010/main" Requires="a14">
+      <mc:AlternateContent xmlns:mc="http://schemas.openxmlformats.org/markup-compatibility/2006" xmlns:a14="http://schemas.microsoft.com/office/drawing/2010/main">
+        <mc:Choice Requires="a14">
           <p:sp>
             <p:nvSpPr>
               <p:cNvPr id="3" name="Content Placeholder 2">
@@ -6840,7 +7309,7 @@
             </p:txBody>
           </p:sp>
         </mc:Choice>
-        <mc:Fallback>
+        <mc:Fallback xmlns="">
           <p:sp>
             <p:nvSpPr>
               <p:cNvPr id="3" name="Content Placeholder 2">
@@ -6878,6 +7347,57 @@
               </a:p>
             </p:txBody>
           </p:sp>
+        </mc:Fallback>
+      </mc:AlternateContent>
+      <mc:AlternateContent xmlns:mc="http://schemas.openxmlformats.org/markup-compatibility/2006">
+        <mc:Choice xmlns:p14="http://schemas.microsoft.com/office/powerpoint/2010/main" Requires="p14">
+          <p:contentPart p14:bwMode="auto" r:id="rId3">
+            <p14:nvContentPartPr>
+              <p14:cNvPr id="4" name="Ink 3">
+                <a:extLst>
+                  <a:ext uri="{FF2B5EF4-FFF2-40B4-BE49-F238E27FC236}">
+                    <a16:creationId xmlns:a16="http://schemas.microsoft.com/office/drawing/2014/main" id="{3792D865-ED40-AEBD-29B9-CF77BADBFF2C}"/>
+                  </a:ext>
+                </a:extLst>
+              </p14:cNvPr>
+              <p14:cNvContentPartPr/>
+              <p14:nvPr/>
+            </p14:nvContentPartPr>
+            <p14:xfrm>
+              <a:off x="2006640" y="4667040"/>
+              <a:ext cx="559080" cy="64440"/>
+            </p14:xfrm>
+          </p:contentPart>
+        </mc:Choice>
+        <mc:Fallback>
+          <p:pic>
+            <p:nvPicPr>
+              <p:cNvPr id="4" name="Ink 3">
+                <a:extLst>
+                  <a:ext uri="{FF2B5EF4-FFF2-40B4-BE49-F238E27FC236}">
+                    <a16:creationId xmlns:a16="http://schemas.microsoft.com/office/drawing/2014/main" id="{3792D865-ED40-AEBD-29B9-CF77BADBFF2C}"/>
+                  </a:ext>
+                </a:extLst>
+              </p:cNvPr>
+              <p:cNvPicPr/>
+              <p:nvPr/>
+            </p:nvPicPr>
+            <p:blipFill>
+              <a:blip r:embed="rId4"/>
+              <a:stretch>
+                <a:fillRect/>
+              </a:stretch>
+            </p:blipFill>
+            <p:spPr>
+              <a:xfrm>
+                <a:off x="1997280" y="4657680"/>
+                <a:ext cx="577800" cy="83160"/>
+              </a:xfrm>
+              <a:prstGeom prst="rect">
+                <a:avLst/>
+              </a:prstGeom>
+            </p:spPr>
+          </p:pic>
         </mc:Fallback>
       </mc:AlternateContent>
     </p:spTree>
@@ -6948,8 +7468,8 @@
           </a:p>
         </p:txBody>
       </p:sp>
-      <mc:AlternateContent xmlns:mc="http://schemas.openxmlformats.org/markup-compatibility/2006">
-        <mc:Choice xmlns:a14="http://schemas.microsoft.com/office/drawing/2010/main" Requires="a14">
+      <mc:AlternateContent xmlns:mc="http://schemas.openxmlformats.org/markup-compatibility/2006" xmlns:a14="http://schemas.microsoft.com/office/drawing/2010/main">
+        <mc:Choice Requires="a14">
           <p:sp>
             <p:nvSpPr>
               <p:cNvPr id="3" name="Content Placeholder 2">
@@ -7192,7 +7712,7 @@
             </p:txBody>
           </p:sp>
         </mc:Choice>
-        <mc:Fallback>
+        <mc:Fallback xmlns="">
           <p:sp>
             <p:nvSpPr>
               <p:cNvPr id="3" name="Content Placeholder 2">
@@ -7230,6 +7750,57 @@
               </a:p>
             </p:txBody>
           </p:sp>
+        </mc:Fallback>
+      </mc:AlternateContent>
+      <mc:AlternateContent xmlns:mc="http://schemas.openxmlformats.org/markup-compatibility/2006">
+        <mc:Choice xmlns:p14="http://schemas.microsoft.com/office/powerpoint/2010/main" Requires="p14">
+          <p:contentPart p14:bwMode="auto" r:id="rId3">
+            <p14:nvContentPartPr>
+              <p14:cNvPr id="4" name="Ink 3">
+                <a:extLst>
+                  <a:ext uri="{FF2B5EF4-FFF2-40B4-BE49-F238E27FC236}">
+                    <a16:creationId xmlns:a16="http://schemas.microsoft.com/office/drawing/2014/main" id="{E7DD8CD8-0E6D-AD9E-716A-25B0296D84D2}"/>
+                  </a:ext>
+                </a:extLst>
+              </p14:cNvPr>
+              <p14:cNvContentPartPr/>
+              <p14:nvPr/>
+            </p14:nvContentPartPr>
+            <p14:xfrm>
+              <a:off x="1720800" y="5454720"/>
+              <a:ext cx="241560" cy="360"/>
+            </p14:xfrm>
+          </p:contentPart>
+        </mc:Choice>
+        <mc:Fallback>
+          <p:pic>
+            <p:nvPicPr>
+              <p:cNvPr id="4" name="Ink 3">
+                <a:extLst>
+                  <a:ext uri="{FF2B5EF4-FFF2-40B4-BE49-F238E27FC236}">
+                    <a16:creationId xmlns:a16="http://schemas.microsoft.com/office/drawing/2014/main" id="{E7DD8CD8-0E6D-AD9E-716A-25B0296D84D2}"/>
+                  </a:ext>
+                </a:extLst>
+              </p:cNvPr>
+              <p:cNvPicPr/>
+              <p:nvPr/>
+            </p:nvPicPr>
+            <p:blipFill>
+              <a:blip r:embed="rId4"/>
+              <a:stretch>
+                <a:fillRect/>
+              </a:stretch>
+            </p:blipFill>
+            <p:spPr>
+              <a:xfrm>
+                <a:off x="1711440" y="5445360"/>
+                <a:ext cx="260280" cy="19080"/>
+              </a:xfrm>
+              <a:prstGeom prst="rect">
+                <a:avLst/>
+              </a:prstGeom>
+            </p:spPr>
+          </p:pic>
         </mc:Fallback>
       </mc:AlternateContent>
     </p:spTree>
@@ -7616,6 +8187,57 @@
           </p:sp>
         </mc:Fallback>
       </mc:AlternateContent>
+      <mc:AlternateContent xmlns:mc="http://schemas.openxmlformats.org/markup-compatibility/2006">
+        <mc:Choice xmlns:p14="http://schemas.microsoft.com/office/powerpoint/2010/main" Requires="p14">
+          <p:contentPart p14:bwMode="auto" r:id="rId3">
+            <p14:nvContentPartPr>
+              <p14:cNvPr id="4" name="Ink 3">
+                <a:extLst>
+                  <a:ext uri="{FF2B5EF4-FFF2-40B4-BE49-F238E27FC236}">
+                    <a16:creationId xmlns:a16="http://schemas.microsoft.com/office/drawing/2014/main" id="{CFFB0C25-5C16-16AA-E3F3-33E87CB767F8}"/>
+                  </a:ext>
+                </a:extLst>
+              </p14:cNvPr>
+              <p14:cNvContentPartPr/>
+              <p14:nvPr/>
+            </p14:nvContentPartPr>
+            <p14:xfrm>
+              <a:off x="571680" y="4590360"/>
+              <a:ext cx="3689640" cy="1030320"/>
+            </p14:xfrm>
+          </p:contentPart>
+        </mc:Choice>
+        <mc:Fallback>
+          <p:pic>
+            <p:nvPicPr>
+              <p:cNvPr id="4" name="Ink 3">
+                <a:extLst>
+                  <a:ext uri="{FF2B5EF4-FFF2-40B4-BE49-F238E27FC236}">
+                    <a16:creationId xmlns:a16="http://schemas.microsoft.com/office/drawing/2014/main" id="{CFFB0C25-5C16-16AA-E3F3-33E87CB767F8}"/>
+                  </a:ext>
+                </a:extLst>
+              </p:cNvPr>
+              <p:cNvPicPr/>
+              <p:nvPr/>
+            </p:nvPicPr>
+            <p:blipFill>
+              <a:blip r:embed="rId4"/>
+              <a:stretch>
+                <a:fillRect/>
+              </a:stretch>
+            </p:blipFill>
+            <p:spPr>
+              <a:xfrm>
+                <a:off x="562320" y="4581000"/>
+                <a:ext cx="3708360" cy="1049040"/>
+              </a:xfrm>
+              <a:prstGeom prst="rect">
+                <a:avLst/>
+              </a:prstGeom>
+            </p:spPr>
+          </p:pic>
+        </mc:Fallback>
+      </mc:AlternateContent>
     </p:spTree>
     <p:extLst>
       <p:ext uri="{BB962C8B-B14F-4D97-AF65-F5344CB8AC3E}">
@@ -7834,8 +8456,8 @@
           <a:chExt cx="0" cy="0"/>
         </a:xfrm>
       </p:grpSpPr>
-      <mc:AlternateContent xmlns:mc="http://schemas.openxmlformats.org/markup-compatibility/2006">
-        <mc:Choice xmlns:a14="http://schemas.microsoft.com/office/drawing/2010/main" Requires="a14">
+      <mc:AlternateContent xmlns:mc="http://schemas.openxmlformats.org/markup-compatibility/2006" xmlns:a14="http://schemas.microsoft.com/office/drawing/2010/main">
+        <mc:Choice Requires="a14">
           <p:sp>
             <p:nvSpPr>
               <p:cNvPr id="2" name="Title 1">
@@ -7909,7 +8531,7 @@
             </p:txBody>
           </p:sp>
         </mc:Choice>
-        <mc:Fallback>
+        <mc:Fallback xmlns="">
           <p:sp>
             <p:nvSpPr>
               <p:cNvPr id="2" name="Title 1">
@@ -7949,8 +8571,8 @@
           </p:sp>
         </mc:Fallback>
       </mc:AlternateContent>
-      <mc:AlternateContent xmlns:mc="http://schemas.openxmlformats.org/markup-compatibility/2006">
-        <mc:Choice xmlns:a14="http://schemas.microsoft.com/office/drawing/2010/main" Requires="a14">
+      <mc:AlternateContent xmlns:mc="http://schemas.openxmlformats.org/markup-compatibility/2006" xmlns:a14="http://schemas.microsoft.com/office/drawing/2010/main">
+        <mc:Choice Requires="a14">
           <p:sp>
             <p:nvSpPr>
               <p:cNvPr id="3" name="Content Placeholder 2">
@@ -7999,7 +8621,7 @@
             </p:txBody>
           </p:sp>
         </mc:Choice>
-        <mc:Fallback>
+        <mc:Fallback xmlns="">
           <p:sp>
             <p:nvSpPr>
               <p:cNvPr id="3" name="Content Placeholder 2">
@@ -8293,8 +8915,8 @@
           <a:chExt cx="0" cy="0"/>
         </a:xfrm>
       </p:grpSpPr>
-      <mc:AlternateContent xmlns:mc="http://schemas.openxmlformats.org/markup-compatibility/2006">
-        <mc:Choice xmlns:a14="http://schemas.microsoft.com/office/drawing/2010/main" Requires="a14">
+      <mc:AlternateContent xmlns:mc="http://schemas.openxmlformats.org/markup-compatibility/2006" xmlns:a14="http://schemas.microsoft.com/office/drawing/2010/main">
+        <mc:Choice Requires="a14">
           <p:sp>
             <p:nvSpPr>
               <p:cNvPr id="2" name="Title 1">
@@ -8393,7 +9015,7 @@
             </p:txBody>
           </p:sp>
         </mc:Choice>
-        <mc:Fallback>
+        <mc:Fallback xmlns="">
           <p:sp>
             <p:nvSpPr>
               <p:cNvPr id="2" name="Title 1">
@@ -8433,8 +9055,8 @@
           </p:sp>
         </mc:Fallback>
       </mc:AlternateContent>
-      <mc:AlternateContent xmlns:mc="http://schemas.openxmlformats.org/markup-compatibility/2006">
-        <mc:Choice xmlns:a14="http://schemas.microsoft.com/office/drawing/2010/main" Requires="a14">
+      <mc:AlternateContent xmlns:mc="http://schemas.openxmlformats.org/markup-compatibility/2006" xmlns:a14="http://schemas.microsoft.com/office/drawing/2010/main">
+        <mc:Choice Requires="a14">
           <p:sp>
             <p:nvSpPr>
               <p:cNvPr id="3" name="Content Placeholder 2">
@@ -8508,7 +9130,7 @@
             </p:txBody>
           </p:sp>
         </mc:Choice>
-        <mc:Fallback>
+        <mc:Fallback xmlns="">
           <p:sp>
             <p:nvSpPr>
               <p:cNvPr id="3" name="Content Placeholder 2">
@@ -8919,8 +9541,8 @@
           <a:chExt cx="0" cy="0"/>
         </a:xfrm>
       </p:grpSpPr>
-      <mc:AlternateContent xmlns:mc="http://schemas.openxmlformats.org/markup-compatibility/2006">
-        <mc:Choice xmlns:a14="http://schemas.microsoft.com/office/drawing/2010/main" Requires="a14">
+      <mc:AlternateContent xmlns:mc="http://schemas.openxmlformats.org/markup-compatibility/2006" xmlns:a14="http://schemas.microsoft.com/office/drawing/2010/main">
+        <mc:Choice Requires="a14">
           <p:sp>
             <p:nvSpPr>
               <p:cNvPr id="2" name="Title 1">
@@ -9033,7 +9655,7 @@
             </p:txBody>
           </p:sp>
         </mc:Choice>
-        <mc:Fallback>
+        <mc:Fallback xmlns="">
           <p:sp>
             <p:nvSpPr>
               <p:cNvPr id="2" name="Title 1">
@@ -9073,8 +9695,8 @@
           </p:sp>
         </mc:Fallback>
       </mc:AlternateContent>
-      <mc:AlternateContent xmlns:mc="http://schemas.openxmlformats.org/markup-compatibility/2006">
-        <mc:Choice xmlns:a14="http://schemas.microsoft.com/office/drawing/2010/main" Requires="a14">
+      <mc:AlternateContent xmlns:mc="http://schemas.openxmlformats.org/markup-compatibility/2006" xmlns:a14="http://schemas.microsoft.com/office/drawing/2010/main">
+        <mc:Choice Requires="a14">
           <p:sp>
             <p:nvSpPr>
               <p:cNvPr id="3" name="Content Placeholder 2">
@@ -9160,7 +9782,7 @@
             </p:txBody>
           </p:sp>
         </mc:Choice>
-        <mc:Fallback>
+        <mc:Fallback xmlns="">
           <p:sp>
             <p:nvSpPr>
               <p:cNvPr id="3" name="Content Placeholder 2">
@@ -9934,8 +10556,8 @@
           </a:p>
         </p:txBody>
       </p:sp>
-      <mc:AlternateContent xmlns:mc="http://schemas.openxmlformats.org/markup-compatibility/2006">
-        <mc:Choice xmlns:a14="http://schemas.microsoft.com/office/drawing/2010/main" Requires="a14">
+      <mc:AlternateContent xmlns:mc="http://schemas.openxmlformats.org/markup-compatibility/2006" xmlns:a14="http://schemas.microsoft.com/office/drawing/2010/main">
+        <mc:Choice Requires="a14">
           <p:sp>
             <p:nvSpPr>
               <p:cNvPr id="3" name="Content Placeholder 2">
@@ -10071,7 +10693,7 @@
             </p:txBody>
           </p:sp>
         </mc:Choice>
-        <mc:Fallback>
+        <mc:Fallback xmlns="">
           <p:sp>
             <p:nvSpPr>
               <p:cNvPr id="3" name="Content Placeholder 2">
@@ -10181,8 +10803,8 @@
           </a:p>
         </p:txBody>
       </p:sp>
-      <mc:AlternateContent xmlns:mc="http://schemas.openxmlformats.org/markup-compatibility/2006">
-        <mc:Choice xmlns:a14="http://schemas.microsoft.com/office/drawing/2010/main" Requires="a14">
+      <mc:AlternateContent xmlns:mc="http://schemas.openxmlformats.org/markup-compatibility/2006" xmlns:a14="http://schemas.microsoft.com/office/drawing/2010/main">
+        <mc:Choice Requires="a14">
           <p:sp>
             <p:nvSpPr>
               <p:cNvPr id="3" name="Content Placeholder 2">
@@ -10362,7 +10984,7 @@
             </p:txBody>
           </p:sp>
         </mc:Choice>
-        <mc:Fallback>
+        <mc:Fallback xmlns="">
           <p:sp>
             <p:nvSpPr>
               <p:cNvPr id="3" name="Content Placeholder 2">
@@ -10472,8 +11094,8 @@
           </a:p>
         </p:txBody>
       </p:sp>
-      <mc:AlternateContent xmlns:mc="http://schemas.openxmlformats.org/markup-compatibility/2006">
-        <mc:Choice xmlns:a14="http://schemas.microsoft.com/office/drawing/2010/main" Requires="a14">
+      <mc:AlternateContent xmlns:mc="http://schemas.openxmlformats.org/markup-compatibility/2006" xmlns:a14="http://schemas.microsoft.com/office/drawing/2010/main">
+        <mc:Choice Requires="a14">
           <p:sp>
             <p:nvSpPr>
               <p:cNvPr id="3" name="Content Placeholder 2">
@@ -10567,7 +11189,7 @@
             </p:txBody>
           </p:sp>
         </mc:Choice>
-        <mc:Fallback>
+        <mc:Fallback xmlns="">
           <p:sp>
             <p:nvSpPr>
               <p:cNvPr id="3" name="Content Placeholder 2">
@@ -10677,8 +11299,8 @@
           </a:p>
         </p:txBody>
       </p:sp>
-      <mc:AlternateContent xmlns:mc="http://schemas.openxmlformats.org/markup-compatibility/2006">
-        <mc:Choice xmlns:a14="http://schemas.microsoft.com/office/drawing/2010/main" Requires="a14">
+      <mc:AlternateContent xmlns:mc="http://schemas.openxmlformats.org/markup-compatibility/2006" xmlns:a14="http://schemas.microsoft.com/office/drawing/2010/main">
+        <mc:Choice Requires="a14">
           <p:sp>
             <p:nvSpPr>
               <p:cNvPr id="3" name="Content Placeholder 2">
@@ -10844,7 +11466,7 @@
             </p:txBody>
           </p:sp>
         </mc:Choice>
-        <mc:Fallback>
+        <mc:Fallback xmlns="">
           <p:sp>
             <p:nvSpPr>
               <p:cNvPr id="3" name="Content Placeholder 2">
@@ -12383,8 +13005,8 @@
           </a:p>
         </p:txBody>
       </p:sp>
-      <mc:AlternateContent xmlns:mc="http://schemas.openxmlformats.org/markup-compatibility/2006">
-        <mc:Choice xmlns:a14="http://schemas.microsoft.com/office/drawing/2010/main" Requires="a14">
+      <mc:AlternateContent xmlns:mc="http://schemas.openxmlformats.org/markup-compatibility/2006" xmlns:a14="http://schemas.microsoft.com/office/drawing/2010/main">
+        <mc:Choice Requires="a14">
           <p:graphicFrame>
             <p:nvGraphicFramePr>
               <p:cNvPr id="6" name="Table 5">
@@ -12407,7 +13029,7 @@
             </p:nvGraphicFramePr>
             <p:xfrm>
               <a:off x="1391478" y="2542032"/>
-              <a:ext cx="8955156" cy="3338640"/>
+              <a:ext cx="8955156" cy="3337560"/>
             </p:xfrm>
             <a:graphic>
               <a:graphicData uri="http://schemas.openxmlformats.org/drawingml/2006/table">
@@ -12529,19 +13151,27 @@
                               </m:oMathParaPr>
                               <m:oMath xmlns:m="http://schemas.openxmlformats.org/officeDocument/2006/math">
                                 <m:r>
-                                  <a:rPr lang="en-CA" b="0" smtClean="0"/>
+                                  <a:rPr lang="en-CA" b="0" smtClean="0">
+                                    <a:latin typeface="Cambria Math" panose="02040503050406030204" pitchFamily="18" charset="0"/>
+                                  </a:rPr>
                                   <m:t>𝑂</m:t>
                                 </m:r>
                                 <m:r>
-                                  <a:rPr lang="en-CA" b="0" smtClean="0"/>
+                                  <a:rPr lang="en-CA" b="0" smtClean="0">
+                                    <a:latin typeface="Cambria Math" panose="02040503050406030204" pitchFamily="18" charset="0"/>
+                                  </a:rPr>
                                   <m:t>(</m:t>
                                 </m:r>
                                 <m:r>
-                                  <a:rPr lang="en-CA" b="0" smtClean="0"/>
+                                  <a:rPr lang="en-CA" b="0" smtClean="0">
+                                    <a:latin typeface="Cambria Math" panose="02040503050406030204" pitchFamily="18" charset="0"/>
+                                  </a:rPr>
                                   <m:t>𝑛</m:t>
                                 </m:r>
                                 <m:r>
-                                  <a:rPr lang="en-CA" b="0" smtClean="0"/>
+                                  <a:rPr lang="en-CA" b="0" smtClean="0">
+                                    <a:latin typeface="Cambria Math" panose="02040503050406030204" pitchFamily="18" charset="0"/>
+                                  </a:rPr>
                                   <m:t>)</m:t>
                                 </m:r>
                               </m:oMath>
@@ -12600,19 +13230,27 @@
                               </m:oMathParaPr>
                               <m:oMath xmlns:m="http://schemas.openxmlformats.org/officeDocument/2006/math">
                                 <m:r>
-                                  <a:rPr lang="en-CA" b="0" smtClean="0"/>
+                                  <a:rPr lang="en-CA" b="0" smtClean="0">
+                                    <a:latin typeface="Cambria Math" panose="02040503050406030204" pitchFamily="18" charset="0"/>
+                                  </a:rPr>
                                   <m:t>𝑂</m:t>
                                 </m:r>
                                 <m:r>
-                                  <a:rPr lang="en-CA" b="0" smtClean="0"/>
+                                  <a:rPr lang="en-CA" b="0" smtClean="0">
+                                    <a:latin typeface="Cambria Math" panose="02040503050406030204" pitchFamily="18" charset="0"/>
+                                  </a:rPr>
                                   <m:t>(</m:t>
                                 </m:r>
                                 <m:r>
-                                  <a:rPr lang="en-CA" b="0" smtClean="0"/>
+                                  <a:rPr lang="en-CA" b="0" smtClean="0">
+                                    <a:latin typeface="Cambria Math" panose="02040503050406030204" pitchFamily="18" charset="0"/>
+                                  </a:rPr>
                                   <m:t>𝑛</m:t>
                                 </m:r>
                                 <m:r>
-                                  <a:rPr lang="en-CA" b="0" smtClean="0"/>
+                                  <a:rPr lang="en-CA" b="0" smtClean="0">
+                                    <a:latin typeface="Cambria Math" panose="02040503050406030204" pitchFamily="18" charset="0"/>
+                                  </a:rPr>
                                   <m:t>)</m:t>
                                 </m:r>
                               </m:oMath>
@@ -12641,24 +13279,32 @@
                               <m:sSup>
                                 <m:sSupPr>
                                   <m:ctrlPr>
-                                    <a:rPr lang="en-US" dirty="0" smtClean="0"/>
+                                    <a:rPr lang="en-US" i="1" dirty="0" smtClean="0">
+                                      <a:latin typeface="Cambria Math" panose="02040503050406030204" pitchFamily="18" charset="0"/>
+                                    </a:rPr>
                                   </m:ctrlPr>
                                 </m:sSupPr>
                                 <m:e>
                                   <m:r>
-                                    <a:rPr lang="en-US" dirty="0" smtClean="0"/>
+                                    <a:rPr lang="en-US" dirty="0" smtClean="0">
+                                      <a:latin typeface="Cambria Math" panose="02040503050406030204" pitchFamily="18" charset="0"/>
+                                    </a:rPr>
                                     <m:t>𝑎</m:t>
                                   </m:r>
                                 </m:e>
                                 <m:sup>
                                   <m:r>
-                                    <a:rPr lang="en-US" dirty="0" smtClean="0"/>
+                                    <a:rPr lang="en-US" dirty="0" smtClean="0">
+                                      <a:latin typeface="Cambria Math" panose="02040503050406030204" pitchFamily="18" charset="0"/>
+                                    </a:rPr>
                                     <m:t>𝑛</m:t>
                                   </m:r>
                                 </m:sup>
                               </m:sSup>
                               <m:r>
-                                <a:rPr lang="en-US" dirty="0" smtClean="0"/>
+                                <a:rPr lang="en-US" dirty="0" smtClean="0">
+                                  <a:latin typeface="Cambria Math" panose="02040503050406030204" pitchFamily="18" charset="0"/>
+                                </a:rPr>
                                 <m:t> </m:t>
                               </m:r>
                             </m:oMath>
@@ -12698,19 +13344,27 @@
                               </m:oMathParaPr>
                               <m:oMath xmlns:m="http://schemas.openxmlformats.org/officeDocument/2006/math">
                                 <m:r>
-                                  <a:rPr lang="en-CA" b="0" smtClean="0"/>
+                                  <a:rPr lang="en-CA" b="0" smtClean="0">
+                                    <a:latin typeface="Cambria Math" panose="02040503050406030204" pitchFamily="18" charset="0"/>
+                                  </a:rPr>
                                   <m:t>𝑂</m:t>
                                 </m:r>
                                 <m:r>
-                                  <a:rPr lang="en-CA" b="0" smtClean="0"/>
+                                  <a:rPr lang="en-CA" b="0" smtClean="0">
+                                    <a:latin typeface="Cambria Math" panose="02040503050406030204" pitchFamily="18" charset="0"/>
+                                  </a:rPr>
                                   <m:t>(</m:t>
                                 </m:r>
                                 <m:r>
-                                  <a:rPr lang="en-CA" b="0" smtClean="0"/>
+                                  <a:rPr lang="en-CA" b="0" smtClean="0">
+                                    <a:latin typeface="Cambria Math" panose="02040503050406030204" pitchFamily="18" charset="0"/>
+                                  </a:rPr>
                                   <m:t>𝑛</m:t>
                                 </m:r>
                                 <m:r>
-                                  <a:rPr lang="en-CA" b="0" smtClean="0"/>
+                                  <a:rPr lang="en-CA" b="0" smtClean="0">
+                                    <a:latin typeface="Cambria Math" panose="02040503050406030204" pitchFamily="18" charset="0"/>
+                                  </a:rPr>
                                   <m:t>)</m:t>
                                 </m:r>
                               </m:oMath>
@@ -12739,24 +13393,32 @@
                               <m:sSup>
                                 <m:sSupPr>
                                   <m:ctrlPr>
-                                    <a:rPr lang="en-US" dirty="0" smtClean="0"/>
+                                    <a:rPr lang="en-US" i="1" dirty="0" smtClean="0">
+                                      <a:latin typeface="Cambria Math" panose="02040503050406030204" pitchFamily="18" charset="0"/>
+                                    </a:rPr>
                                   </m:ctrlPr>
                                 </m:sSupPr>
                                 <m:e>
                                   <m:r>
-                                    <a:rPr lang="en-US" dirty="0" smtClean="0"/>
+                                    <a:rPr lang="en-US" dirty="0" smtClean="0">
+                                      <a:latin typeface="Cambria Math" panose="02040503050406030204" pitchFamily="18" charset="0"/>
+                                    </a:rPr>
                                     <m:t>𝑎</m:t>
                                   </m:r>
                                 </m:e>
                                 <m:sup>
                                   <m:r>
-                                    <a:rPr lang="en-US" dirty="0" smtClean="0"/>
+                                    <a:rPr lang="en-US" dirty="0" smtClean="0">
+                                      <a:latin typeface="Cambria Math" panose="02040503050406030204" pitchFamily="18" charset="0"/>
+                                    </a:rPr>
                                     <m:t>𝑛</m:t>
                                   </m:r>
                                 </m:sup>
                               </m:sSup>
                               <m:r>
-                                <a:rPr lang="en-US" dirty="0" smtClean="0"/>
+                                <a:rPr lang="en-US" dirty="0" smtClean="0">
+                                  <a:latin typeface="Cambria Math" panose="02040503050406030204" pitchFamily="18" charset="0"/>
+                                </a:rPr>
                                 <m:t> </m:t>
                               </m:r>
                             </m:oMath>
@@ -12817,17 +13479,23 @@
                               </m:oMathParaPr>
                               <m:oMath xmlns:m="http://schemas.openxmlformats.org/officeDocument/2006/math">
                                 <m:r>
-                                  <a:rPr lang="en-CA" b="0" smtClean="0"/>
+                                  <a:rPr lang="en-CA" b="0" smtClean="0">
+                                    <a:latin typeface="Cambria Math" panose="02040503050406030204" pitchFamily="18" charset="0"/>
+                                  </a:rPr>
                                   <m:t>𝑂</m:t>
                                 </m:r>
                                 <m:r>
-                                  <a:rPr lang="en-CA" b="0" smtClean="0"/>
+                                  <a:rPr lang="en-CA" b="0" smtClean="0">
+                                    <a:latin typeface="Cambria Math" panose="02040503050406030204" pitchFamily="18" charset="0"/>
+                                  </a:rPr>
                                   <m:t>(</m:t>
                                 </m:r>
                                 <m:func>
                                   <m:funcPr>
                                     <m:ctrlPr>
-                                      <a:rPr lang="en-CA" b="0" smtClean="0"/>
+                                      <a:rPr lang="en-CA" b="0" i="1" smtClean="0">
+                                        <a:latin typeface="Cambria Math" panose="02040503050406030204" pitchFamily="18" charset="0"/>
+                                      </a:rPr>
                                     </m:ctrlPr>
                                   </m:funcPr>
                                   <m:fName>
@@ -12835,19 +13503,25 @@
                                       <m:rPr>
                                         <m:sty m:val="p"/>
                                       </m:rPr>
-                                      <a:rPr lang="en-CA" b="0" smtClean="0"/>
+                                      <a:rPr lang="en-CA" b="0" smtClean="0">
+                                        <a:latin typeface="Cambria Math" panose="02040503050406030204" pitchFamily="18" charset="0"/>
+                                      </a:rPr>
                                       <m:t>log</m:t>
                                     </m:r>
                                   </m:fName>
                                   <m:e>
                                     <m:r>
-                                      <a:rPr lang="en-CA" b="0" smtClean="0"/>
+                                      <a:rPr lang="en-CA" b="0" smtClean="0">
+                                        <a:latin typeface="Cambria Math" panose="02040503050406030204" pitchFamily="18" charset="0"/>
+                                      </a:rPr>
                                       <m:t>𝑛</m:t>
                                     </m:r>
                                   </m:e>
                                 </m:func>
                                 <m:r>
-                                  <a:rPr lang="en-CA" b="0" smtClean="0"/>
+                                  <a:rPr lang="en-CA" b="0" smtClean="0">
+                                    <a:latin typeface="Cambria Math" panose="02040503050406030204" pitchFamily="18" charset="0"/>
+                                  </a:rPr>
                                   <m:t>)</m:t>
                                 </m:r>
                               </m:oMath>
@@ -12906,19 +13580,27 @@
                               </m:oMathParaPr>
                               <m:oMath xmlns:m="http://schemas.openxmlformats.org/officeDocument/2006/math">
                                 <m:r>
-                                  <a:rPr lang="en-CA" b="0" smtClean="0"/>
+                                  <a:rPr lang="en-CA" b="0" smtClean="0">
+                                    <a:latin typeface="Cambria Math" panose="02040503050406030204" pitchFamily="18" charset="0"/>
+                                  </a:rPr>
                                   <m:t>𝑂</m:t>
                                 </m:r>
                                 <m:r>
-                                  <a:rPr lang="en-CA" b="0" smtClean="0"/>
+                                  <a:rPr lang="en-CA" b="0" smtClean="0">
+                                    <a:latin typeface="Cambria Math" panose="02040503050406030204" pitchFamily="18" charset="0"/>
+                                  </a:rPr>
                                   <m:t>(</m:t>
                                 </m:r>
                                 <m:r>
-                                  <a:rPr lang="en-CA" b="0" smtClean="0"/>
+                                  <a:rPr lang="en-CA" b="0" smtClean="0">
+                                    <a:latin typeface="Cambria Math" panose="02040503050406030204" pitchFamily="18" charset="0"/>
+                                  </a:rPr>
                                   <m:t>𝑛</m:t>
                                 </m:r>
                                 <m:r>
-                                  <a:rPr lang="en-CA" b="0" smtClean="0"/>
+                                  <a:rPr lang="en-CA" b="0" smtClean="0">
+                                    <a:latin typeface="Cambria Math" panose="02040503050406030204" pitchFamily="18" charset="0"/>
+                                  </a:rPr>
                                   <m:t>)</m:t>
                                 </m:r>
                               </m:oMath>
@@ -12977,34 +13659,46 @@
                               </m:oMathParaPr>
                               <m:oMath xmlns:m="http://schemas.openxmlformats.org/officeDocument/2006/math">
                                 <m:r>
-                                  <a:rPr lang="en-CA" b="0" smtClean="0"/>
+                                  <a:rPr lang="en-CA" b="0" smtClean="0">
+                                    <a:latin typeface="Cambria Math" panose="02040503050406030204" pitchFamily="18" charset="0"/>
+                                  </a:rPr>
                                   <m:t>𝑂</m:t>
                                 </m:r>
                                 <m:r>
-                                  <a:rPr lang="en-CA" b="0" smtClean="0"/>
+                                  <a:rPr lang="en-CA" b="0" smtClean="0">
+                                    <a:latin typeface="Cambria Math" panose="02040503050406030204" pitchFamily="18" charset="0"/>
+                                  </a:rPr>
                                   <m:t>(</m:t>
                                 </m:r>
                                 <m:sSup>
                                   <m:sSupPr>
                                     <m:ctrlPr>
-                                      <a:rPr lang="en-CA" b="0" smtClean="0"/>
+                                      <a:rPr lang="en-CA" b="0" i="1" smtClean="0">
+                                        <a:latin typeface="Cambria Math" panose="02040503050406030204" pitchFamily="18" charset="0"/>
+                                      </a:rPr>
                                     </m:ctrlPr>
                                   </m:sSupPr>
                                   <m:e>
                                     <m:r>
-                                      <a:rPr lang="en-CA" b="0" smtClean="0"/>
+                                      <a:rPr lang="en-CA" b="0" smtClean="0">
+                                        <a:latin typeface="Cambria Math" panose="02040503050406030204" pitchFamily="18" charset="0"/>
+                                      </a:rPr>
                                       <m:t>𝑛</m:t>
                                     </m:r>
                                   </m:e>
                                   <m:sup>
                                     <m:r>
-                                      <a:rPr lang="en-CA" b="0" smtClean="0"/>
+                                      <a:rPr lang="en-CA" b="0" smtClean="0">
+                                        <a:latin typeface="Cambria Math" panose="02040503050406030204" pitchFamily="18" charset="0"/>
+                                      </a:rPr>
                                       <m:t>2</m:t>
                                     </m:r>
                                   </m:sup>
                                 </m:sSup>
                                 <m:r>
-                                  <a:rPr lang="en-CA" b="0" smtClean="0"/>
+                                  <a:rPr lang="en-CA" b="0" smtClean="0">
+                                    <a:latin typeface="Cambria Math" panose="02040503050406030204" pitchFamily="18" charset="0"/>
+                                  </a:rPr>
                                   <m:t>)</m:t>
                                 </m:r>
                               </m:oMath>
@@ -13064,21 +13758,29 @@
                               </m:oMathParaPr>
                               <m:oMath xmlns:m="http://schemas.openxmlformats.org/officeDocument/2006/math">
                                 <m:r>
-                                  <a:rPr lang="en-CA" b="0" smtClean="0"/>
+                                  <a:rPr lang="en-CA" b="0" smtClean="0">
+                                    <a:latin typeface="Cambria Math" panose="02040503050406030204" pitchFamily="18" charset="0"/>
+                                  </a:rPr>
                                   <m:t>𝑂</m:t>
                                 </m:r>
                                 <m:r>
-                                  <a:rPr lang="en-CA" b="0" smtClean="0"/>
+                                  <a:rPr lang="en-CA" b="0" smtClean="0">
+                                    <a:latin typeface="Cambria Math" panose="02040503050406030204" pitchFamily="18" charset="0"/>
+                                  </a:rPr>
                                   <m:t>(</m:t>
                                 </m:r>
                                 <m:r>
-                                  <a:rPr lang="en-CA" b="0" smtClean="0"/>
+                                  <a:rPr lang="en-CA" b="0" smtClean="0">
+                                    <a:latin typeface="Cambria Math" panose="02040503050406030204" pitchFamily="18" charset="0"/>
+                                  </a:rPr>
                                   <m:t>𝑛</m:t>
                                 </m:r>
                                 <m:func>
                                   <m:funcPr>
                                     <m:ctrlPr>
-                                      <a:rPr lang="en-CA" b="0" smtClean="0"/>
+                                      <a:rPr lang="en-CA" b="0" i="1" smtClean="0">
+                                        <a:latin typeface="Cambria Math" panose="02040503050406030204" pitchFamily="18" charset="0"/>
+                                      </a:rPr>
                                     </m:ctrlPr>
                                   </m:funcPr>
                                   <m:fName>
@@ -13086,19 +13788,25 @@
                                       <m:rPr>
                                         <m:sty m:val="p"/>
                                       </m:rPr>
-                                      <a:rPr lang="en-CA" b="0" smtClean="0"/>
+                                      <a:rPr lang="en-CA" b="0" smtClean="0">
+                                        <a:latin typeface="Cambria Math" panose="02040503050406030204" pitchFamily="18" charset="0"/>
+                                      </a:rPr>
                                       <m:t>log</m:t>
                                     </m:r>
                                   </m:fName>
                                   <m:e>
                                     <m:r>
-                                      <a:rPr lang="en-CA" b="0" smtClean="0"/>
+                                      <a:rPr lang="en-CA" b="0" smtClean="0">
+                                        <a:latin typeface="Cambria Math" panose="02040503050406030204" pitchFamily="18" charset="0"/>
+                                      </a:rPr>
                                       <m:t>𝑛</m:t>
                                     </m:r>
                                   </m:e>
                                 </m:func>
                                 <m:r>
-                                  <a:rPr lang="en-CA" b="0" smtClean="0"/>
+                                  <a:rPr lang="en-CA" b="0" smtClean="0">
+                                    <a:latin typeface="Cambria Math" panose="02040503050406030204" pitchFamily="18" charset="0"/>
+                                  </a:rPr>
                                   <m:t>)</m:t>
                                 </m:r>
                               </m:oMath>
@@ -13157,17 +13865,23 @@
                               </m:oMathParaPr>
                               <m:oMath xmlns:m="http://schemas.openxmlformats.org/officeDocument/2006/math">
                                 <m:r>
-                                  <a:rPr lang="en-CA" b="0" smtClean="0"/>
+                                  <a:rPr lang="en-CA" b="0" smtClean="0">
+                                    <a:latin typeface="Cambria Math" panose="02040503050406030204" pitchFamily="18" charset="0"/>
+                                  </a:rPr>
                                   <m:t>𝑂</m:t>
                                 </m:r>
                                 <m:r>
-                                  <a:rPr lang="en-CA" b="0" smtClean="0"/>
+                                  <a:rPr lang="en-CA" b="0" smtClean="0">
+                                    <a:latin typeface="Cambria Math" panose="02040503050406030204" pitchFamily="18" charset="0"/>
+                                  </a:rPr>
                                   <m:t>(</m:t>
                                 </m:r>
                                 <m:func>
                                   <m:funcPr>
                                     <m:ctrlPr>
-                                      <a:rPr lang="en-CA" b="0" smtClean="0"/>
+                                      <a:rPr lang="en-CA" b="0" i="1" smtClean="0">
+                                        <a:latin typeface="Cambria Math" panose="02040503050406030204" pitchFamily="18" charset="0"/>
+                                      </a:rPr>
                                     </m:ctrlPr>
                                   </m:funcPr>
                                   <m:fName>
@@ -13175,19 +13889,25 @@
                                       <m:rPr>
                                         <m:sty m:val="p"/>
                                       </m:rPr>
-                                      <a:rPr lang="en-CA" b="0" smtClean="0"/>
+                                      <a:rPr lang="en-CA" b="0" smtClean="0">
+                                        <a:latin typeface="Cambria Math" panose="02040503050406030204" pitchFamily="18" charset="0"/>
+                                      </a:rPr>
                                       <m:t>log</m:t>
                                     </m:r>
                                   </m:fName>
                                   <m:e>
                                     <m:r>
-                                      <a:rPr lang="en-CA" b="0" smtClean="0"/>
+                                      <a:rPr lang="en-CA" b="0" smtClean="0">
+                                        <a:latin typeface="Cambria Math" panose="02040503050406030204" pitchFamily="18" charset="0"/>
+                                      </a:rPr>
                                       <m:t>𝑛</m:t>
                                     </m:r>
                                   </m:e>
                                 </m:func>
                                 <m:r>
-                                  <a:rPr lang="en-CA" b="0" smtClean="0"/>
+                                  <a:rPr lang="en-CA" b="0" smtClean="0">
+                                    <a:latin typeface="Cambria Math" panose="02040503050406030204" pitchFamily="18" charset="0"/>
+                                  </a:rPr>
                                   <m:t>)</m:t>
                                 </m:r>
                               </m:oMath>
@@ -13209,7 +13929,7 @@
             </a:graphic>
           </p:graphicFrame>
         </mc:Choice>
-        <mc:Fallback>
+        <mc:Fallback xmlns="">
           <p:graphicFrame>
             <p:nvGraphicFramePr>
               <p:cNvPr id="6" name="Table 5">
@@ -13741,6 +14461,57 @@
           </p:graphicFrame>
         </mc:Fallback>
       </mc:AlternateContent>
+      <mc:AlternateContent xmlns:mc="http://schemas.openxmlformats.org/markup-compatibility/2006">
+        <mc:Choice xmlns:p14="http://schemas.microsoft.com/office/powerpoint/2010/main" Requires="p14">
+          <p:contentPart p14:bwMode="auto" r:id="rId3">
+            <p14:nvContentPartPr>
+              <p14:cNvPr id="3" name="Ink 2">
+                <a:extLst>
+                  <a:ext uri="{FF2B5EF4-FFF2-40B4-BE49-F238E27FC236}">
+                    <a16:creationId xmlns:a16="http://schemas.microsoft.com/office/drawing/2014/main" id="{94E6AD5E-B385-E95E-E689-3E9F56B8868E}"/>
+                  </a:ext>
+                </a:extLst>
+              </p14:cNvPr>
+              <p14:cNvContentPartPr/>
+              <p14:nvPr/>
+            </p14:nvContentPartPr>
+            <p14:xfrm>
+              <a:off x="9003600" y="4863960"/>
+              <a:ext cx="45360" cy="743400"/>
+            </p14:xfrm>
+          </p:contentPart>
+        </mc:Choice>
+        <mc:Fallback>
+          <p:pic>
+            <p:nvPicPr>
+              <p:cNvPr id="3" name="Ink 2">
+                <a:extLst>
+                  <a:ext uri="{FF2B5EF4-FFF2-40B4-BE49-F238E27FC236}">
+                    <a16:creationId xmlns:a16="http://schemas.microsoft.com/office/drawing/2014/main" id="{94E6AD5E-B385-E95E-E689-3E9F56B8868E}"/>
+                  </a:ext>
+                </a:extLst>
+              </p:cNvPr>
+              <p:cNvPicPr/>
+              <p:nvPr/>
+            </p:nvPicPr>
+            <p:blipFill>
+              <a:blip r:embed="rId4"/>
+              <a:stretch>
+                <a:fillRect/>
+              </a:stretch>
+            </p:blipFill>
+            <p:spPr>
+              <a:xfrm>
+                <a:off x="8994240" y="4854600"/>
+                <a:ext cx="64080" cy="762120"/>
+              </a:xfrm>
+              <a:prstGeom prst="rect">
+                <a:avLst/>
+              </a:prstGeom>
+            </p:spPr>
+          </p:pic>
+        </mc:Fallback>
+      </mc:AlternateContent>
     </p:spTree>
     <p:extLst>
       <p:ext uri="{BB962C8B-B14F-4D97-AF65-F5344CB8AC3E}">
@@ -14003,6 +14774,57 @@
               </a:p>
             </p:txBody>
           </p:sp>
+        </mc:Fallback>
+      </mc:AlternateContent>
+      <mc:AlternateContent xmlns:mc="http://schemas.openxmlformats.org/markup-compatibility/2006">
+        <mc:Choice xmlns:p14="http://schemas.microsoft.com/office/powerpoint/2010/main" Requires="p14">
+          <p:contentPart p14:bwMode="auto" r:id="rId3">
+            <p14:nvContentPartPr>
+              <p14:cNvPr id="4" name="Ink 3">
+                <a:extLst>
+                  <a:ext uri="{FF2B5EF4-FFF2-40B4-BE49-F238E27FC236}">
+                    <a16:creationId xmlns:a16="http://schemas.microsoft.com/office/drawing/2014/main" id="{CC49B7AE-68BF-276D-43BB-7DA43AD7AEA9}"/>
+                  </a:ext>
+                </a:extLst>
+              </p14:cNvPr>
+              <p14:cNvContentPartPr/>
+              <p14:nvPr/>
+            </p14:nvContentPartPr>
+            <p14:xfrm>
+              <a:off x="558720" y="3790800"/>
+              <a:ext cx="1391040" cy="45360"/>
+            </p14:xfrm>
+          </p:contentPart>
+        </mc:Choice>
+        <mc:Fallback>
+          <p:pic>
+            <p:nvPicPr>
+              <p:cNvPr id="4" name="Ink 3">
+                <a:extLst>
+                  <a:ext uri="{FF2B5EF4-FFF2-40B4-BE49-F238E27FC236}">
+                    <a16:creationId xmlns:a16="http://schemas.microsoft.com/office/drawing/2014/main" id="{CC49B7AE-68BF-276D-43BB-7DA43AD7AEA9}"/>
+                  </a:ext>
+                </a:extLst>
+              </p:cNvPr>
+              <p:cNvPicPr/>
+              <p:nvPr/>
+            </p:nvPicPr>
+            <p:blipFill>
+              <a:blip r:embed="rId4"/>
+              <a:stretch>
+                <a:fillRect/>
+              </a:stretch>
+            </p:blipFill>
+            <p:spPr>
+              <a:xfrm>
+                <a:off x="549360" y="3781440"/>
+                <a:ext cx="1409760" cy="64080"/>
+              </a:xfrm>
+              <a:prstGeom prst="rect">
+                <a:avLst/>
+              </a:prstGeom>
+            </p:spPr>
+          </p:pic>
         </mc:Fallback>
       </mc:AlternateContent>
     </p:spTree>
@@ -15580,6 +16402,57 @@
               </a:p>
             </p:txBody>
           </p:sp>
+        </mc:Fallback>
+      </mc:AlternateContent>
+      <mc:AlternateContent xmlns:mc="http://schemas.openxmlformats.org/markup-compatibility/2006">
+        <mc:Choice xmlns:p14="http://schemas.microsoft.com/office/powerpoint/2010/main" Requires="p14">
+          <p:contentPart p14:bwMode="auto" r:id="rId3">
+            <p14:nvContentPartPr>
+              <p14:cNvPr id="4" name="Ink 3">
+                <a:extLst>
+                  <a:ext uri="{FF2B5EF4-FFF2-40B4-BE49-F238E27FC236}">
+                    <a16:creationId xmlns:a16="http://schemas.microsoft.com/office/drawing/2014/main" id="{3BF4E456-0989-9D62-AAAB-F0351919CDA5}"/>
+                  </a:ext>
+                </a:extLst>
+              </p14:cNvPr>
+              <p14:cNvContentPartPr/>
+              <p14:nvPr/>
+            </p14:nvContentPartPr>
+            <p14:xfrm>
+              <a:off x="635040" y="4489560"/>
+              <a:ext cx="2661120" cy="70200"/>
+            </p14:xfrm>
+          </p:contentPart>
+        </mc:Choice>
+        <mc:Fallback>
+          <p:pic>
+            <p:nvPicPr>
+              <p:cNvPr id="4" name="Ink 3">
+                <a:extLst>
+                  <a:ext uri="{FF2B5EF4-FFF2-40B4-BE49-F238E27FC236}">
+                    <a16:creationId xmlns:a16="http://schemas.microsoft.com/office/drawing/2014/main" id="{3BF4E456-0989-9D62-AAAB-F0351919CDA5}"/>
+                  </a:ext>
+                </a:extLst>
+              </p:cNvPr>
+              <p:cNvPicPr/>
+              <p:nvPr/>
+            </p:nvPicPr>
+            <p:blipFill>
+              <a:blip r:embed="rId4"/>
+              <a:stretch>
+                <a:fillRect/>
+              </a:stretch>
+            </p:blipFill>
+            <p:spPr>
+              <a:xfrm>
+                <a:off x="625680" y="4480200"/>
+                <a:ext cx="2679840" cy="88920"/>
+              </a:xfrm>
+              <a:prstGeom prst="rect">
+                <a:avLst/>
+              </a:prstGeom>
+            </p:spPr>
+          </p:pic>
         </mc:Fallback>
       </mc:AlternateContent>
     </p:spTree>
@@ -16199,6 +17072,57 @@
               </a:p>
             </p:txBody>
           </p:sp>
+        </mc:Fallback>
+      </mc:AlternateContent>
+      <mc:AlternateContent xmlns:mc="http://schemas.openxmlformats.org/markup-compatibility/2006">
+        <mc:Choice xmlns:p14="http://schemas.microsoft.com/office/powerpoint/2010/main" Requires="p14">
+          <p:contentPart p14:bwMode="auto" r:id="rId3">
+            <p14:nvContentPartPr>
+              <p14:cNvPr id="4" name="Ink 3">
+                <a:extLst>
+                  <a:ext uri="{FF2B5EF4-FFF2-40B4-BE49-F238E27FC236}">
+                    <a16:creationId xmlns:a16="http://schemas.microsoft.com/office/drawing/2014/main" id="{E44B9B83-D443-72E0-6C8A-427AF5677ECA}"/>
+                  </a:ext>
+                </a:extLst>
+              </p14:cNvPr>
+              <p14:cNvContentPartPr/>
+              <p14:nvPr/>
+            </p14:nvContentPartPr>
+            <p14:xfrm>
+              <a:off x="1720800" y="5269680"/>
+              <a:ext cx="305280" cy="20160"/>
+            </p14:xfrm>
+          </p:contentPart>
+        </mc:Choice>
+        <mc:Fallback>
+          <p:pic>
+            <p:nvPicPr>
+              <p:cNvPr id="4" name="Ink 3">
+                <a:extLst>
+                  <a:ext uri="{FF2B5EF4-FFF2-40B4-BE49-F238E27FC236}">
+                    <a16:creationId xmlns:a16="http://schemas.microsoft.com/office/drawing/2014/main" id="{E44B9B83-D443-72E0-6C8A-427AF5677ECA}"/>
+                  </a:ext>
+                </a:extLst>
+              </p:cNvPr>
+              <p:cNvPicPr/>
+              <p:nvPr/>
+            </p:nvPicPr>
+            <p:blipFill>
+              <a:blip r:embed="rId4"/>
+              <a:stretch>
+                <a:fillRect/>
+              </a:stretch>
+            </p:blipFill>
+            <p:spPr>
+              <a:xfrm>
+                <a:off x="1711440" y="5260320"/>
+                <a:ext cx="324000" cy="38880"/>
+              </a:xfrm>
+              <a:prstGeom prst="rect">
+                <a:avLst/>
+              </a:prstGeom>
+            </p:spPr>
+          </p:pic>
         </mc:Fallback>
       </mc:AlternateContent>
     </p:spTree>
@@ -17299,6 +18223,57 @@
           </p:sp>
         </mc:Fallback>
       </mc:AlternateContent>
+      <mc:AlternateContent xmlns:mc="http://schemas.openxmlformats.org/markup-compatibility/2006">
+        <mc:Choice xmlns:p14="http://schemas.microsoft.com/office/powerpoint/2010/main" Requires="p14">
+          <p:contentPart p14:bwMode="auto" r:id="rId3">
+            <p14:nvContentPartPr>
+              <p14:cNvPr id="4" name="Ink 3">
+                <a:extLst>
+                  <a:ext uri="{FF2B5EF4-FFF2-40B4-BE49-F238E27FC236}">
+                    <a16:creationId xmlns:a16="http://schemas.microsoft.com/office/drawing/2014/main" id="{576F59BB-4F0B-C277-980F-51CD69BDA6D2}"/>
+                  </a:ext>
+                </a:extLst>
+              </p14:cNvPr>
+              <p14:cNvContentPartPr/>
+              <p14:nvPr/>
+            </p14:nvContentPartPr>
+            <p14:xfrm>
+              <a:off x="469800" y="2190240"/>
+              <a:ext cx="11196000" cy="1195200"/>
+            </p14:xfrm>
+          </p:contentPart>
+        </mc:Choice>
+        <mc:Fallback>
+          <p:pic>
+            <p:nvPicPr>
+              <p:cNvPr id="4" name="Ink 3">
+                <a:extLst>
+                  <a:ext uri="{FF2B5EF4-FFF2-40B4-BE49-F238E27FC236}">
+                    <a16:creationId xmlns:a16="http://schemas.microsoft.com/office/drawing/2014/main" id="{576F59BB-4F0B-C277-980F-51CD69BDA6D2}"/>
+                  </a:ext>
+                </a:extLst>
+              </p:cNvPr>
+              <p:cNvPicPr/>
+              <p:nvPr/>
+            </p:nvPicPr>
+            <p:blipFill>
+              <a:blip r:embed="rId4"/>
+              <a:stretch>
+                <a:fillRect/>
+              </a:stretch>
+            </p:blipFill>
+            <p:spPr>
+              <a:xfrm>
+                <a:off x="460440" y="2180880"/>
+                <a:ext cx="11214720" cy="1213920"/>
+              </a:xfrm>
+              <a:prstGeom prst="rect">
+                <a:avLst/>
+              </a:prstGeom>
+            </p:spPr>
+          </p:pic>
+        </mc:Fallback>
+      </mc:AlternateContent>
     </p:spTree>
     <p:extLst>
       <p:ext uri="{BB962C8B-B14F-4D97-AF65-F5344CB8AC3E}">
@@ -17363,8 +18338,8 @@
           </a:p>
         </p:txBody>
       </p:sp>
-      <mc:AlternateContent xmlns:mc="http://schemas.openxmlformats.org/markup-compatibility/2006">
-        <mc:Choice xmlns:a14="http://schemas.microsoft.com/office/drawing/2010/main" Requires="a14">
+      <mc:AlternateContent xmlns:mc="http://schemas.openxmlformats.org/markup-compatibility/2006" xmlns:a14="http://schemas.microsoft.com/office/drawing/2010/main">
+        <mc:Choice Requires="a14">
           <p:sp>
             <p:nvSpPr>
               <p:cNvPr id="3" name="Content Placeholder 2">
@@ -17775,7 +18750,7 @@
             </p:txBody>
           </p:sp>
         </mc:Choice>
-        <mc:Fallback>
+        <mc:Fallback xmlns="">
           <p:sp>
             <p:nvSpPr>
               <p:cNvPr id="3" name="Content Placeholder 2">
@@ -18542,8 +19517,8 @@
           </a:p>
         </p:txBody>
       </p:sp>
-      <mc:AlternateContent xmlns:mc="http://schemas.openxmlformats.org/markup-compatibility/2006">
-        <mc:Choice xmlns:a14="http://schemas.microsoft.com/office/drawing/2010/main" Requires="a14">
+      <mc:AlternateContent xmlns:mc="http://schemas.openxmlformats.org/markup-compatibility/2006" xmlns:a14="http://schemas.microsoft.com/office/drawing/2010/main">
+        <mc:Choice Requires="a14">
           <p:sp>
             <p:nvSpPr>
               <p:cNvPr id="3" name="Content Placeholder 2">
@@ -19200,7 +20175,7 @@
             </p:txBody>
           </p:sp>
         </mc:Choice>
-        <mc:Fallback>
+        <mc:Fallback xmlns="">
           <p:sp>
             <p:nvSpPr>
               <p:cNvPr id="3" name="Content Placeholder 2">
@@ -20080,8 +21055,8 @@
           </a:p>
         </p:txBody>
       </p:sp>
-      <mc:AlternateContent xmlns:mc="http://schemas.openxmlformats.org/markup-compatibility/2006">
-        <mc:Choice xmlns:a14="http://schemas.microsoft.com/office/drawing/2010/main" Requires="a14">
+      <mc:AlternateContent xmlns:mc="http://schemas.openxmlformats.org/markup-compatibility/2006" xmlns:a14="http://schemas.microsoft.com/office/drawing/2010/main">
+        <mc:Choice Requires="a14">
           <p:sp>
             <p:nvSpPr>
               <p:cNvPr id="3" name="Content Placeholder 2">
@@ -20802,7 +21777,7 @@
             </p:txBody>
           </p:sp>
         </mc:Choice>
-        <mc:Fallback>
+        <mc:Fallback xmlns="">
           <p:sp>
             <p:nvSpPr>
               <p:cNvPr id="3" name="Content Placeholder 2">

</xml_diff>